<commit_message>
feat: rebuild report matching 南福岡グリーンホテル reference format
7-slide structure aligned with reference PDF:
1. 表紙 — 自動導入経過報告、セブンデイズホテル、手間いらず株式会社
2. 導入内容 — 3項目（料金在庫管理/TP設定/販売チャネル自動調整）
3. 変動履歴：3月 — 日別テーブル（15日×2段）＋棒グラフ＋累計折れ線
4. 変動履歴：4月 — 同上
5. 昨対比較（セクション区切り）— 青背景 TEMAIRAZU スタイル
6. 月次実績比較 — 平均サマリテーブル＋OCC/ADR/RevPAR/売上グループ棒グラフ
7. 運用変化 — Before（手動）/ After（自動）比較ボックス

https://claude.ai/code/session_013p7F6AUiJGj2eg3zLyAtsN
</commit_message>
<xml_diff>
--- a/sevendays_report.pptx
+++ b/sevendays_report.pptx
@@ -9,6 +9,9 @@
     <p:sldId id="257" r:id="rId8"/>
     <p:sldId id="258" r:id="rId9"/>
     <p:sldId id="259" r:id="rId10"/>
+    <p:sldId id="260" r:id="rId11"/>
+    <p:sldId id="261" r:id="rId12"/>
+    <p:sldId id="262" r:id="rId13"/>
   </p:sldIdLst>
   <p:sldSz cx="12188952" cy="6858000" type="screen4x3"/>
   <p:notesSz cx="6858000" cy="9144000"/>
@@ -3100,13 +3103,13 @@
         <p:spPr>
           <a:xfrm>
             <a:off x="0" y="0"/>
-            <a:ext cx="12188952" cy="1463040"/>
+            <a:ext cx="12188952" cy="6858000"/>
           </a:xfrm>
           <a:prstGeom prst="rect">
             <a:avLst/>
           </a:prstGeom>
           <a:solidFill>
-            <a:srgbClr val="1F497D"/>
+            <a:srgbClr val="F0F0F0"/>
           </a:solidFill>
           <a:ln>
             <a:noFill/>
@@ -3136,14 +3139,57 @@
       </p:sp>
       <p:sp>
         <p:nvSpPr>
-          <p:cNvPr id="3" name="TextBox 2"/>
+          <p:cNvPr id="3" name="Rectangle 2"/>
+          <p:cNvSpPr/>
+          <p:nvPr/>
+        </p:nvSpPr>
+        <p:spPr>
+          <a:xfrm>
+            <a:off x="3474720" y="2743200"/>
+            <a:ext cx="8412480" cy="1554480"/>
+          </a:xfrm>
+          <a:prstGeom prst="rect">
+            <a:avLst/>
+          </a:prstGeom>
+          <a:solidFill>
+            <a:srgbClr val="BDD7EE"/>
+          </a:solidFill>
+          <a:ln>
+            <a:noFill/>
+          </a:ln>
+        </p:spPr>
+        <p:style>
+          <a:lnRef idx="1">
+            <a:schemeClr val="accent1"/>
+          </a:lnRef>
+          <a:fillRef idx="3">
+            <a:schemeClr val="accent1"/>
+          </a:fillRef>
+          <a:effectRef idx="2">
+            <a:schemeClr val="accent1"/>
+          </a:effectRef>
+          <a:fontRef idx="minor">
+            <a:schemeClr val="lt1"/>
+          </a:fontRef>
+        </p:style>
+        <p:txBody>
+          <a:bodyPr rtlCol="0" anchor="ctr"/>
+          <a:lstStyle/>
+          <a:p>
+            <a:pPr algn="ctr"/>
+          </a:p>
+        </p:txBody>
+      </p:sp>
+      <p:sp>
+        <p:nvSpPr>
+          <p:cNvPr id="4" name="TextBox 3"/>
           <p:cNvSpPr txBox="1"/>
           <p:nvPr/>
         </p:nvSpPr>
         <p:spPr>
           <a:xfrm>
-            <a:off x="457200" y="365760"/>
-            <a:ext cx="10972800" cy="777240"/>
+            <a:off x="3474720" y="2788920"/>
+            <a:ext cx="8412480" cy="731520"/>
           </a:xfrm>
           <a:prstGeom prst="rect">
             <a:avLst/>
@@ -3156,28 +3202,28 @@
           </a:bodyPr>
           <a:lstStyle/>
           <a:p>
-            <a:pPr algn="l"/>
+            <a:pPr algn="ctr"/>
             <a:r>
               <a:rPr sz="2800" b="1">
                 <a:solidFill>
-                  <a:srgbClr val="FFFFFF"/>
+                  <a:srgbClr val="1F3864"/>
                 </a:solidFill>
               </a:rPr>
-              <a:t>施設レポート</a:t>
-            </a:r>
-          </a:p>
-        </p:txBody>
-      </p:sp>
-      <p:sp>
-        <p:nvSpPr>
-          <p:cNvPr id="4" name="TextBox 3"/>
+              <a:t>自動導入経過報告</a:t>
+            </a:r>
+          </a:p>
+        </p:txBody>
+      </p:sp>
+      <p:sp>
+        <p:nvSpPr>
+          <p:cNvPr id="5" name="TextBox 4"/>
           <p:cNvSpPr txBox="1"/>
           <p:nvPr/>
         </p:nvSpPr>
         <p:spPr>
           <a:xfrm>
-            <a:off x="457200" y="1828800"/>
-            <a:ext cx="10972800" cy="1097280"/>
+            <a:off x="3474720" y="3493008"/>
+            <a:ext cx="8412480" cy="548640"/>
           </a:xfrm>
           <a:prstGeom prst="rect">
             <a:avLst/>
@@ -3190,11 +3236,45 @@
           </a:bodyPr>
           <a:lstStyle/>
           <a:p>
-            <a:pPr algn="l"/>
-            <a:r>
-              <a:rPr sz="4000" b="1">
+            <a:pPr algn="ctr"/>
+            <a:r>
+              <a:rPr sz="1700" b="0">
                 <a:solidFill>
-                  <a:srgbClr val="1F497D"/>
+                  <a:srgbClr val="252525"/>
+                </a:solidFill>
+              </a:rPr>
+              <a:t>— 2026年1月〜2026年4月 —</a:t>
+            </a:r>
+          </a:p>
+        </p:txBody>
+      </p:sp>
+      <p:sp>
+        <p:nvSpPr>
+          <p:cNvPr id="6" name="TextBox 5"/>
+          <p:cNvSpPr txBox="1"/>
+          <p:nvPr/>
+        </p:nvSpPr>
+        <p:spPr>
+          <a:xfrm>
+            <a:off x="6858000" y="4663440"/>
+            <a:ext cx="5029200" cy="777240"/>
+          </a:xfrm>
+          <a:prstGeom prst="rect">
+            <a:avLst/>
+          </a:prstGeom>
+          <a:noFill/>
+        </p:spPr>
+        <p:txBody>
+          <a:bodyPr wrap="none">
+            <a:spAutoFit/>
+          </a:bodyPr>
+          <a:lstStyle/>
+          <a:p>
+            <a:pPr algn="r"/>
+            <a:r>
+              <a:rPr sz="2600" b="1">
+                <a:solidFill>
+                  <a:srgbClr val="1F3864"/>
                 </a:solidFill>
               </a:rPr>
               <a:t>セブンデイズホテル</a:t>
@@ -3204,14 +3284,14 @@
       </p:sp>
       <p:sp>
         <p:nvSpPr>
-          <p:cNvPr id="5" name="TextBox 4"/>
+          <p:cNvPr id="7" name="TextBox 6"/>
           <p:cNvSpPr txBox="1"/>
           <p:nvPr/>
         </p:nvSpPr>
         <p:spPr>
           <a:xfrm>
-            <a:off x="457200" y="3200400"/>
-            <a:ext cx="10972800" cy="640080"/>
+            <a:off x="6858000" y="5349240"/>
+            <a:ext cx="5029200" cy="548640"/>
           </a:xfrm>
           <a:prstGeom prst="rect">
             <a:avLst/>
@@ -3224,48 +3304,14 @@
           </a:bodyPr>
           <a:lstStyle/>
           <a:p>
-            <a:pPr algn="l"/>
-            <a:r>
-              <a:rPr sz="2200" b="0">
+            <a:pPr algn="r"/>
+            <a:r>
+              <a:rPr sz="1800" b="0">
                 <a:solidFill>
-                  <a:srgbClr val="404040"/>
+                  <a:srgbClr val="1F3864"/>
                 </a:solidFill>
               </a:rPr>
-              <a:t>2025年2月〜2026年4月</a:t>
-            </a:r>
-          </a:p>
-        </p:txBody>
-      </p:sp>
-      <p:sp>
-        <p:nvSpPr>
-          <p:cNvPr id="6" name="TextBox 5"/>
-          <p:cNvSpPr txBox="1"/>
-          <p:nvPr/>
-        </p:nvSpPr>
-        <p:spPr>
-          <a:xfrm>
-            <a:off x="457200" y="4114800"/>
-            <a:ext cx="10972800" cy="548640"/>
-          </a:xfrm>
-          <a:prstGeom prst="rect">
-            <a:avLst/>
-          </a:prstGeom>
-          <a:noFill/>
-        </p:spPr>
-        <p:txBody>
-          <a:bodyPr wrap="none">
-            <a:spAutoFit/>
-          </a:bodyPr>
-          <a:lstStyle/>
-          <a:p>
-            <a:pPr algn="l"/>
-            <a:r>
-              <a:rPr sz="1500" b="0">
-                <a:solidFill>
-                  <a:srgbClr val="808080"/>
-                </a:solidFill>
-              </a:rPr>
-              <a:t>手間いらず自動　本格運用開始：2026年1月〜</a:t>
+              <a:t>手間いらず株式会社</a:t>
             </a:r>
           </a:p>
         </p:txBody>
@@ -3303,7 +3349,7 @@
             <a:avLst/>
           </a:prstGeom>
           <a:solidFill>
-            <a:srgbClr val="1F497D"/>
+            <a:srgbClr val="1F3864"/>
           </a:solidFill>
           <a:ln>
             <a:noFill/>
@@ -3339,8 +3385,8 @@
         </p:nvSpPr>
         <p:spPr>
           <a:xfrm>
-            <a:off x="274320" y="91440"/>
-            <a:ext cx="11612880" cy="411480"/>
+            <a:off x="320040" y="91440"/>
+            <a:ext cx="11521440" cy="411480"/>
           </a:xfrm>
           <a:prstGeom prst="rect">
             <a:avLst/>
@@ -3353,41 +3399,668 @@
           </a:bodyPr>
           <a:lstStyle/>
           <a:p>
-            <a:r>
-              <a:rPr sz="1800" b="1">
+            <a:pPr algn="ctr"/>
+            <a:r>
+              <a:rPr sz="2000" b="1">
                 <a:solidFill>
                   <a:srgbClr val="FFFFFF"/>
                 </a:solidFill>
               </a:rPr>
-              <a:t>導入前後比較（2025年 vs 2026年　2〜4月）</a:t>
-            </a:r>
-          </a:p>
-        </p:txBody>
-      </p:sp>
-      <p:pic>
-        <p:nvPicPr>
-          <p:cNvPr id="4" name="Picture 3" descr="image.png"/>
-          <p:cNvPicPr>
-            <a:picLocks noChangeAspect="1"/>
-          </p:cNvPicPr>
-          <p:nvPr/>
-        </p:nvPicPr>
-        <p:blipFill>
-          <a:blip r:embed="rId2"/>
-          <a:stretch>
-            <a:fillRect/>
-          </a:stretch>
-        </p:blipFill>
-        <p:spPr>
-          <a:xfrm>
-            <a:off x="365760" y="685800"/>
-            <a:ext cx="11430000" cy="5852160"/>
-          </a:xfrm>
-          <a:prstGeom prst="rect">
-            <a:avLst/>
-          </a:prstGeom>
-        </p:spPr>
-      </p:pic>
+              <a:t>導入内容</a:t>
+            </a:r>
+          </a:p>
+        </p:txBody>
+      </p:sp>
+      <p:sp>
+        <p:nvSpPr>
+          <p:cNvPr id="4" name="Rectangle 3"/>
+          <p:cNvSpPr/>
+          <p:nvPr/>
+        </p:nvSpPr>
+        <p:spPr>
+          <a:xfrm>
+            <a:off x="365760" y="1005840"/>
+            <a:ext cx="3657600" cy="3291840"/>
+          </a:xfrm>
+          <a:prstGeom prst="rect">
+            <a:avLst/>
+          </a:prstGeom>
+          <a:solidFill>
+            <a:srgbClr val="F0F5FB"/>
+          </a:solidFill>
+          <a:ln>
+            <a:solidFill>
+              <a:srgbClr val="BDD7EE"/>
+            </a:solidFill>
+          </a:ln>
+        </p:spPr>
+        <p:style>
+          <a:lnRef idx="1">
+            <a:schemeClr val="accent1"/>
+          </a:lnRef>
+          <a:fillRef idx="3">
+            <a:schemeClr val="accent1"/>
+          </a:fillRef>
+          <a:effectRef idx="2">
+            <a:schemeClr val="accent1"/>
+          </a:effectRef>
+          <a:fontRef idx="minor">
+            <a:schemeClr val="lt1"/>
+          </a:fontRef>
+        </p:style>
+        <p:txBody>
+          <a:bodyPr rtlCol="0" anchor="ctr"/>
+          <a:lstStyle/>
+          <a:p>
+            <a:pPr algn="ctr"/>
+          </a:p>
+        </p:txBody>
+      </p:sp>
+      <p:sp>
+        <p:nvSpPr>
+          <p:cNvPr id="5" name="Rectangle 4"/>
+          <p:cNvSpPr/>
+          <p:nvPr/>
+        </p:nvSpPr>
+        <p:spPr>
+          <a:xfrm>
+            <a:off x="502920" y="1143000"/>
+            <a:ext cx="384048" cy="384048"/>
+          </a:xfrm>
+          <a:prstGeom prst="rect">
+            <a:avLst/>
+          </a:prstGeom>
+          <a:solidFill>
+            <a:srgbClr val="BDD7EE"/>
+          </a:solidFill>
+          <a:ln>
+            <a:noFill/>
+          </a:ln>
+        </p:spPr>
+        <p:style>
+          <a:lnRef idx="1">
+            <a:schemeClr val="accent1"/>
+          </a:lnRef>
+          <a:fillRef idx="3">
+            <a:schemeClr val="accent1"/>
+          </a:fillRef>
+          <a:effectRef idx="2">
+            <a:schemeClr val="accent1"/>
+          </a:effectRef>
+          <a:fontRef idx="minor">
+            <a:schemeClr val="lt1"/>
+          </a:fontRef>
+        </p:style>
+        <p:txBody>
+          <a:bodyPr rtlCol="0" anchor="ctr"/>
+          <a:lstStyle/>
+          <a:p>
+            <a:pPr algn="ctr"/>
+          </a:p>
+        </p:txBody>
+      </p:sp>
+      <p:sp>
+        <p:nvSpPr>
+          <p:cNvPr id="6" name="TextBox 5"/>
+          <p:cNvSpPr txBox="1"/>
+          <p:nvPr/>
+        </p:nvSpPr>
+        <p:spPr>
+          <a:xfrm>
+            <a:off x="502920" y="1143000"/>
+            <a:ext cx="384048" cy="384048"/>
+          </a:xfrm>
+          <a:prstGeom prst="rect">
+            <a:avLst/>
+          </a:prstGeom>
+          <a:noFill/>
+        </p:spPr>
+        <p:txBody>
+          <a:bodyPr wrap="none">
+            <a:spAutoFit/>
+          </a:bodyPr>
+          <a:lstStyle/>
+          <a:p>
+            <a:pPr algn="ctr"/>
+            <a:r>
+              <a:rPr sz="1300" b="1">
+                <a:solidFill>
+                  <a:srgbClr val="1F3864"/>
+                </a:solidFill>
+              </a:rPr>
+              <a:t>1</a:t>
+            </a:r>
+          </a:p>
+        </p:txBody>
+      </p:sp>
+      <p:sp>
+        <p:nvSpPr>
+          <p:cNvPr id="7" name="TextBox 6"/>
+          <p:cNvSpPr txBox="1"/>
+          <p:nvPr/>
+        </p:nvSpPr>
+        <p:spPr>
+          <a:xfrm>
+            <a:off x="548640" y="1600200"/>
+            <a:ext cx="3291840" cy="822960"/>
+          </a:xfrm>
+          <a:prstGeom prst="rect">
+            <a:avLst/>
+          </a:prstGeom>
+          <a:noFill/>
+        </p:spPr>
+        <p:txBody>
+          <a:bodyPr wrap="square">
+            <a:spAutoFit/>
+          </a:bodyPr>
+          <a:lstStyle/>
+          <a:p>
+            <a:pPr algn="l"/>
+            <a:r>
+              <a:rPr sz="1300" b="1">
+                <a:solidFill>
+                  <a:srgbClr val="252525"/>
+                </a:solidFill>
+              </a:rPr>
+              <a:t>料金在庫管理販売期間</a:t>
+            </a:r>
+          </a:p>
+        </p:txBody>
+      </p:sp>
+      <p:sp>
+        <p:nvSpPr>
+          <p:cNvPr id="8" name="TextBox 7"/>
+          <p:cNvSpPr txBox="1"/>
+          <p:nvPr/>
+        </p:nvSpPr>
+        <p:spPr>
+          <a:xfrm>
+            <a:off x="548640" y="2468880"/>
+            <a:ext cx="3291840" cy="1645920"/>
+          </a:xfrm>
+          <a:prstGeom prst="rect">
+            <a:avLst/>
+          </a:prstGeom>
+          <a:noFill/>
+        </p:spPr>
+        <p:txBody>
+          <a:bodyPr wrap="square">
+            <a:spAutoFit/>
+          </a:bodyPr>
+          <a:lstStyle/>
+          <a:p>
+            <a:pPr algn="l"/>
+            <a:r>
+              <a:rPr sz="1100" b="0">
+                <a:solidFill>
+                  <a:srgbClr val="252525"/>
+                </a:solidFill>
+              </a:rPr>
+              <a:t>12か月先（365日先）まで、
+24時間体制で「料金」「在庫」を自動監視</a:t>
+            </a:r>
+          </a:p>
+        </p:txBody>
+      </p:sp>
+      <p:sp>
+        <p:nvSpPr>
+          <p:cNvPr id="9" name="Rectangle 8"/>
+          <p:cNvSpPr/>
+          <p:nvPr/>
+        </p:nvSpPr>
+        <p:spPr>
+          <a:xfrm>
+            <a:off x="4206240" y="1005840"/>
+            <a:ext cx="3657600" cy="3291840"/>
+          </a:xfrm>
+          <a:prstGeom prst="rect">
+            <a:avLst/>
+          </a:prstGeom>
+          <a:solidFill>
+            <a:srgbClr val="F0F5FB"/>
+          </a:solidFill>
+          <a:ln>
+            <a:solidFill>
+              <a:srgbClr val="BDD7EE"/>
+            </a:solidFill>
+          </a:ln>
+        </p:spPr>
+        <p:style>
+          <a:lnRef idx="1">
+            <a:schemeClr val="accent1"/>
+          </a:lnRef>
+          <a:fillRef idx="3">
+            <a:schemeClr val="accent1"/>
+          </a:fillRef>
+          <a:effectRef idx="2">
+            <a:schemeClr val="accent1"/>
+          </a:effectRef>
+          <a:fontRef idx="minor">
+            <a:schemeClr val="lt1"/>
+          </a:fontRef>
+        </p:style>
+        <p:txBody>
+          <a:bodyPr rtlCol="0" anchor="ctr"/>
+          <a:lstStyle/>
+          <a:p>
+            <a:pPr algn="ctr"/>
+          </a:p>
+        </p:txBody>
+      </p:sp>
+      <p:sp>
+        <p:nvSpPr>
+          <p:cNvPr id="10" name="Rectangle 9"/>
+          <p:cNvSpPr/>
+          <p:nvPr/>
+        </p:nvSpPr>
+        <p:spPr>
+          <a:xfrm>
+            <a:off x="4343400" y="1143000"/>
+            <a:ext cx="384048" cy="384048"/>
+          </a:xfrm>
+          <a:prstGeom prst="rect">
+            <a:avLst/>
+          </a:prstGeom>
+          <a:solidFill>
+            <a:srgbClr val="BDD7EE"/>
+          </a:solidFill>
+          <a:ln>
+            <a:noFill/>
+          </a:ln>
+        </p:spPr>
+        <p:style>
+          <a:lnRef idx="1">
+            <a:schemeClr val="accent1"/>
+          </a:lnRef>
+          <a:fillRef idx="3">
+            <a:schemeClr val="accent1"/>
+          </a:fillRef>
+          <a:effectRef idx="2">
+            <a:schemeClr val="accent1"/>
+          </a:effectRef>
+          <a:fontRef idx="minor">
+            <a:schemeClr val="lt1"/>
+          </a:fontRef>
+        </p:style>
+        <p:txBody>
+          <a:bodyPr rtlCol="0" anchor="ctr"/>
+          <a:lstStyle/>
+          <a:p>
+            <a:pPr algn="ctr"/>
+          </a:p>
+        </p:txBody>
+      </p:sp>
+      <p:sp>
+        <p:nvSpPr>
+          <p:cNvPr id="11" name="TextBox 10"/>
+          <p:cNvSpPr txBox="1"/>
+          <p:nvPr/>
+        </p:nvSpPr>
+        <p:spPr>
+          <a:xfrm>
+            <a:off x="4343400" y="1143000"/>
+            <a:ext cx="384048" cy="384048"/>
+          </a:xfrm>
+          <a:prstGeom prst="rect">
+            <a:avLst/>
+          </a:prstGeom>
+          <a:noFill/>
+        </p:spPr>
+        <p:txBody>
+          <a:bodyPr wrap="none">
+            <a:spAutoFit/>
+          </a:bodyPr>
+          <a:lstStyle/>
+          <a:p>
+            <a:pPr algn="ctr"/>
+            <a:r>
+              <a:rPr sz="1300" b="1">
+                <a:solidFill>
+                  <a:srgbClr val="1F3864"/>
+                </a:solidFill>
+              </a:rPr>
+              <a:t>2</a:t>
+            </a:r>
+          </a:p>
+        </p:txBody>
+      </p:sp>
+      <p:sp>
+        <p:nvSpPr>
+          <p:cNvPr id="12" name="TextBox 11"/>
+          <p:cNvSpPr txBox="1"/>
+          <p:nvPr/>
+        </p:nvSpPr>
+        <p:spPr>
+          <a:xfrm>
+            <a:off x="4389120" y="1600200"/>
+            <a:ext cx="3291840" cy="822960"/>
+          </a:xfrm>
+          <a:prstGeom prst="rect">
+            <a:avLst/>
+          </a:prstGeom>
+          <a:noFill/>
+        </p:spPr>
+        <p:txBody>
+          <a:bodyPr wrap="square">
+            <a:spAutoFit/>
+          </a:bodyPr>
+          <a:lstStyle/>
+          <a:p>
+            <a:pPr algn="l"/>
+            <a:r>
+              <a:rPr sz="1300" b="1">
+                <a:solidFill>
+                  <a:srgbClr val="252525"/>
+                </a:solidFill>
+              </a:rPr>
+              <a:t>TP（ターゲットプライス）
+設定ルール</a:t>
+            </a:r>
+          </a:p>
+        </p:txBody>
+      </p:sp>
+      <p:sp>
+        <p:nvSpPr>
+          <p:cNvPr id="13" name="TextBox 12"/>
+          <p:cNvSpPr txBox="1"/>
+          <p:nvPr/>
+        </p:nvSpPr>
+        <p:spPr>
+          <a:xfrm>
+            <a:off x="4389120" y="2468880"/>
+            <a:ext cx="3291840" cy="1645920"/>
+          </a:xfrm>
+          <a:prstGeom prst="rect">
+            <a:avLst/>
+          </a:prstGeom>
+          <a:noFill/>
+        </p:spPr>
+        <p:txBody>
+          <a:bodyPr wrap="square">
+            <a:spAutoFit/>
+          </a:bodyPr>
+          <a:lstStyle/>
+          <a:p>
+            <a:pPr algn="l"/>
+            <a:r>
+              <a:rPr sz="1100" b="0">
+                <a:solidFill>
+                  <a:srgbClr val="252525"/>
+                </a:solidFill>
+              </a:rPr>
+              <a:t>設定ルール
+全部屋 × ランク × 残室数</a:t>
+            </a:r>
+          </a:p>
+        </p:txBody>
+      </p:sp>
+      <p:sp>
+        <p:nvSpPr>
+          <p:cNvPr id="14" name="Rectangle 13"/>
+          <p:cNvSpPr/>
+          <p:nvPr/>
+        </p:nvSpPr>
+        <p:spPr>
+          <a:xfrm>
+            <a:off x="8046720" y="1005840"/>
+            <a:ext cx="3657600" cy="3291840"/>
+          </a:xfrm>
+          <a:prstGeom prst="rect">
+            <a:avLst/>
+          </a:prstGeom>
+          <a:solidFill>
+            <a:srgbClr val="F0F5FB"/>
+          </a:solidFill>
+          <a:ln>
+            <a:solidFill>
+              <a:srgbClr val="BDD7EE"/>
+            </a:solidFill>
+          </a:ln>
+        </p:spPr>
+        <p:style>
+          <a:lnRef idx="1">
+            <a:schemeClr val="accent1"/>
+          </a:lnRef>
+          <a:fillRef idx="3">
+            <a:schemeClr val="accent1"/>
+          </a:fillRef>
+          <a:effectRef idx="2">
+            <a:schemeClr val="accent1"/>
+          </a:effectRef>
+          <a:fontRef idx="minor">
+            <a:schemeClr val="lt1"/>
+          </a:fontRef>
+        </p:style>
+        <p:txBody>
+          <a:bodyPr rtlCol="0" anchor="ctr"/>
+          <a:lstStyle/>
+          <a:p>
+            <a:pPr algn="ctr"/>
+          </a:p>
+        </p:txBody>
+      </p:sp>
+      <p:sp>
+        <p:nvSpPr>
+          <p:cNvPr id="15" name="Rectangle 14"/>
+          <p:cNvSpPr/>
+          <p:nvPr/>
+        </p:nvSpPr>
+        <p:spPr>
+          <a:xfrm>
+            <a:off x="8183880" y="1143000"/>
+            <a:ext cx="384048" cy="384048"/>
+          </a:xfrm>
+          <a:prstGeom prst="rect">
+            <a:avLst/>
+          </a:prstGeom>
+          <a:solidFill>
+            <a:srgbClr val="BDD7EE"/>
+          </a:solidFill>
+          <a:ln>
+            <a:noFill/>
+          </a:ln>
+        </p:spPr>
+        <p:style>
+          <a:lnRef idx="1">
+            <a:schemeClr val="accent1"/>
+          </a:lnRef>
+          <a:fillRef idx="3">
+            <a:schemeClr val="accent1"/>
+          </a:fillRef>
+          <a:effectRef idx="2">
+            <a:schemeClr val="accent1"/>
+          </a:effectRef>
+          <a:fontRef idx="minor">
+            <a:schemeClr val="lt1"/>
+          </a:fontRef>
+        </p:style>
+        <p:txBody>
+          <a:bodyPr rtlCol="0" anchor="ctr"/>
+          <a:lstStyle/>
+          <a:p>
+            <a:pPr algn="ctr"/>
+          </a:p>
+        </p:txBody>
+      </p:sp>
+      <p:sp>
+        <p:nvSpPr>
+          <p:cNvPr id="16" name="TextBox 15"/>
+          <p:cNvSpPr txBox="1"/>
+          <p:nvPr/>
+        </p:nvSpPr>
+        <p:spPr>
+          <a:xfrm>
+            <a:off x="8183880" y="1143000"/>
+            <a:ext cx="384048" cy="384048"/>
+          </a:xfrm>
+          <a:prstGeom prst="rect">
+            <a:avLst/>
+          </a:prstGeom>
+          <a:noFill/>
+        </p:spPr>
+        <p:txBody>
+          <a:bodyPr wrap="none">
+            <a:spAutoFit/>
+          </a:bodyPr>
+          <a:lstStyle/>
+          <a:p>
+            <a:pPr algn="ctr"/>
+            <a:r>
+              <a:rPr sz="1300" b="1">
+                <a:solidFill>
+                  <a:srgbClr val="1F3864"/>
+                </a:solidFill>
+              </a:rPr>
+              <a:t>3</a:t>
+            </a:r>
+          </a:p>
+        </p:txBody>
+      </p:sp>
+      <p:sp>
+        <p:nvSpPr>
+          <p:cNvPr id="17" name="TextBox 16"/>
+          <p:cNvSpPr txBox="1"/>
+          <p:nvPr/>
+        </p:nvSpPr>
+        <p:spPr>
+          <a:xfrm>
+            <a:off x="8229600" y="1600200"/>
+            <a:ext cx="3291840" cy="822960"/>
+          </a:xfrm>
+          <a:prstGeom prst="rect">
+            <a:avLst/>
+          </a:prstGeom>
+          <a:noFill/>
+        </p:spPr>
+        <p:txBody>
+          <a:bodyPr wrap="square">
+            <a:spAutoFit/>
+          </a:bodyPr>
+          <a:lstStyle/>
+          <a:p>
+            <a:pPr algn="l"/>
+            <a:r>
+              <a:rPr sz="1300" b="1">
+                <a:solidFill>
+                  <a:srgbClr val="252525"/>
+                </a:solidFill>
+              </a:rPr>
+              <a:t>販売チャネル 自動調整</a:t>
+            </a:r>
+          </a:p>
+        </p:txBody>
+      </p:sp>
+      <p:sp>
+        <p:nvSpPr>
+          <p:cNvPr id="18" name="TextBox 17"/>
+          <p:cNvSpPr txBox="1"/>
+          <p:nvPr/>
+        </p:nvSpPr>
+        <p:spPr>
+          <a:xfrm>
+            <a:off x="8229600" y="2468880"/>
+            <a:ext cx="3291840" cy="1645920"/>
+          </a:xfrm>
+          <a:prstGeom prst="rect">
+            <a:avLst/>
+          </a:prstGeom>
+          <a:noFill/>
+        </p:spPr>
+        <p:txBody>
+          <a:bodyPr wrap="square">
+            <a:spAutoFit/>
+          </a:bodyPr>
+          <a:lstStyle/>
+          <a:p>
+            <a:pPr algn="l"/>
+            <a:r>
+              <a:rPr sz="1100" b="0">
+                <a:solidFill>
+                  <a:srgbClr val="252525"/>
+                </a:solidFill>
+              </a:rPr>
+              <a:t>稼働率に応じて海外サイトの売止を
+調整し、収益性を向上</a:t>
+            </a:r>
+          </a:p>
+        </p:txBody>
+      </p:sp>
+      <p:sp>
+        <p:nvSpPr>
+          <p:cNvPr id="19" name="Rectangle 18"/>
+          <p:cNvSpPr/>
+          <p:nvPr/>
+        </p:nvSpPr>
+        <p:spPr>
+          <a:xfrm>
+            <a:off x="365760" y="4572000"/>
+            <a:ext cx="11430000" cy="594360"/>
+          </a:xfrm>
+          <a:prstGeom prst="rect">
+            <a:avLst/>
+          </a:prstGeom>
+          <a:solidFill>
+            <a:srgbClr val="D6E4F0"/>
+          </a:solidFill>
+          <a:ln>
+            <a:noFill/>
+          </a:ln>
+        </p:spPr>
+        <p:style>
+          <a:lnRef idx="1">
+            <a:schemeClr val="accent1"/>
+          </a:lnRef>
+          <a:fillRef idx="3">
+            <a:schemeClr val="accent1"/>
+          </a:fillRef>
+          <a:effectRef idx="2">
+            <a:schemeClr val="accent1"/>
+          </a:effectRef>
+          <a:fontRef idx="minor">
+            <a:schemeClr val="lt1"/>
+          </a:fontRef>
+        </p:style>
+        <p:txBody>
+          <a:bodyPr rtlCol="0" anchor="ctr"/>
+          <a:lstStyle/>
+          <a:p>
+            <a:pPr algn="ctr"/>
+          </a:p>
+        </p:txBody>
+      </p:sp>
+      <p:sp>
+        <p:nvSpPr>
+          <p:cNvPr id="20" name="TextBox 19"/>
+          <p:cNvSpPr txBox="1"/>
+          <p:nvPr/>
+        </p:nvSpPr>
+        <p:spPr>
+          <a:xfrm>
+            <a:off x="548640" y="4645152"/>
+            <a:ext cx="11155680" cy="484632"/>
+          </a:xfrm>
+          <a:prstGeom prst="rect">
+            <a:avLst/>
+          </a:prstGeom>
+          <a:noFill/>
+        </p:spPr>
+        <p:txBody>
+          <a:bodyPr wrap="square">
+            <a:spAutoFit/>
+          </a:bodyPr>
+          <a:lstStyle/>
+          <a:p>
+            <a:r>
+              <a:rPr sz="1200">
+                <a:solidFill>
+                  <a:srgbClr val="252525"/>
+                </a:solidFill>
+              </a:rPr>
+              <a:t>✅  自動化により日次の料金確認作業を削減しつつ、手動調整との併用で柔軟なレベニュー運用を実現。</a:t>
+            </a:r>
+          </a:p>
+        </p:txBody>
+      </p:sp>
     </p:spTree>
   </p:cSld>
   <p:clrMapOvr>
@@ -3421,7 +4094,7 @@
             <a:avLst/>
           </a:prstGeom>
           <a:solidFill>
-            <a:srgbClr val="1F497D"/>
+            <a:srgbClr val="1F3864"/>
           </a:solidFill>
           <a:ln>
             <a:noFill/>
@@ -3457,8 +4130,8 @@
         </p:nvSpPr>
         <p:spPr>
           <a:xfrm>
-            <a:off x="274320" y="91440"/>
-            <a:ext cx="11612880" cy="411480"/>
+            <a:off x="320040" y="91440"/>
+            <a:ext cx="11521440" cy="411480"/>
           </a:xfrm>
           <a:prstGeom prst="rect">
             <a:avLst/>
@@ -3471,20 +4144,90 @@
           </a:bodyPr>
           <a:lstStyle/>
           <a:p>
-            <a:r>
-              <a:rPr sz="1800" b="1">
+            <a:pPr algn="ctr"/>
+            <a:r>
+              <a:rPr sz="2000" b="1">
                 <a:solidFill>
                   <a:srgbClr val="FFFFFF"/>
                 </a:solidFill>
               </a:rPr>
-              <a:t>変動回数（デイズ S　2026年3月・4月）</a:t>
+              <a:t>変動履歴対象年月：2026年3月</a:t>
+            </a:r>
+          </a:p>
+        </p:txBody>
+      </p:sp>
+      <p:sp>
+        <p:nvSpPr>
+          <p:cNvPr id="4" name="TextBox 3"/>
+          <p:cNvSpPr txBox="1"/>
+          <p:nvPr/>
+        </p:nvSpPr>
+        <p:spPr>
+          <a:xfrm>
+            <a:off x="365760" y="594360"/>
+            <a:ext cx="2286000" cy="777240"/>
+          </a:xfrm>
+          <a:prstGeom prst="rect">
+            <a:avLst/>
+          </a:prstGeom>
+          <a:noFill/>
+        </p:spPr>
+        <p:txBody>
+          <a:bodyPr wrap="none">
+            <a:spAutoFit/>
+          </a:bodyPr>
+          <a:lstStyle/>
+          <a:p>
+            <a:pPr algn="l"/>
+            <a:r>
+              <a:rPr sz="4200" b="1">
+                <a:solidFill>
+                  <a:srgbClr val="1F3864"/>
+                </a:solidFill>
+              </a:rPr>
+              <a:t>1,192回</a:t>
+            </a:r>
+          </a:p>
+        </p:txBody>
+      </p:sp>
+      <p:sp>
+        <p:nvSpPr>
+          <p:cNvPr id="5" name="TextBox 4"/>
+          <p:cNvSpPr txBox="1"/>
+          <p:nvPr/>
+        </p:nvSpPr>
+        <p:spPr>
+          <a:xfrm>
+            <a:off x="2651760" y="640080"/>
+            <a:ext cx="4572000" cy="685800"/>
+          </a:xfrm>
+          <a:prstGeom prst="rect">
+            <a:avLst/>
+          </a:prstGeom>
+          <a:noFill/>
+        </p:spPr>
+        <p:txBody>
+          <a:bodyPr wrap="square">
+            <a:spAutoFit/>
+          </a:bodyPr>
+          <a:lstStyle/>
+          <a:p>
+            <a:pPr algn="l"/>
+            <a:r>
+              <a:rPr sz="900" b="0">
+                <a:solidFill>
+                  <a:srgbClr val="707070"/>
+                </a:solidFill>
+              </a:rPr>
+              <a:t>※集計期間：2026年1月〜4月
+※対象部屋：デイズ S（全OTAチャネル合計）</a:t>
             </a:r>
           </a:p>
         </p:txBody>
       </p:sp>
       <p:pic>
         <p:nvPicPr>
-          <p:cNvPr id="4" name="Picture 3" descr="image.png"/>
+          <p:cNvPr id="6" name="Picture 5" descr="image.png"/>
           <p:cNvPicPr>
             <a:picLocks noChangeAspect="1"/>
           </p:cNvPicPr>
@@ -3498,8 +4241,8 @@
         </p:blipFill>
         <p:spPr>
           <a:xfrm>
-            <a:off x="274320" y="731520"/>
-            <a:ext cx="4206240" cy="3657600"/>
+            <a:off x="182880" y="1371600"/>
+            <a:ext cx="11795760" cy="4663440"/>
           </a:xfrm>
           <a:prstGeom prst="rect">
             <a:avLst/>
@@ -3508,59 +4251,23 @@
       </p:pic>
       <p:sp>
         <p:nvSpPr>
-          <p:cNvPr id="5" name="TextBox 4"/>
-          <p:cNvSpPr txBox="1"/>
-          <p:nvPr/>
-        </p:nvSpPr>
-        <p:spPr>
-          <a:xfrm>
-            <a:off x="4754880" y="594360"/>
-            <a:ext cx="7132320" cy="347472"/>
-          </a:xfrm>
-          <a:prstGeom prst="rect">
-            <a:avLst/>
-          </a:prstGeom>
-          <a:noFill/>
-        </p:spPr>
-        <p:txBody>
-          <a:bodyPr wrap="none">
-            <a:spAutoFit/>
-          </a:bodyPr>
-          <a:lstStyle/>
-          <a:p>
-            <a:pPr algn="l"/>
-            <a:r>
-              <a:rPr sz="1100" b="1">
-                <a:solidFill>
-                  <a:srgbClr val="1F497D"/>
-                </a:solidFill>
-              </a:rPr>
-              <a:t>3月　変動履歴スクリーンショット（デイズ S）</a:t>
-            </a:r>
-          </a:p>
-        </p:txBody>
-      </p:sp>
-      <p:sp>
-        <p:nvSpPr>
-          <p:cNvPr id="6" name="Rectangle 5"/>
+          <p:cNvPr id="7" name="Rectangle 6"/>
           <p:cNvSpPr/>
           <p:nvPr/>
         </p:nvSpPr>
         <p:spPr>
           <a:xfrm>
-            <a:off x="4754880" y="960120"/>
-            <a:ext cx="7132320" cy="2514600"/>
+            <a:off x="274320" y="6199632"/>
+            <a:ext cx="11612880" cy="530352"/>
           </a:xfrm>
           <a:prstGeom prst="rect">
             <a:avLst/>
           </a:prstGeom>
           <a:solidFill>
-            <a:srgbClr val="F2F2F2"/>
+            <a:srgbClr val="D6E4F0"/>
           </a:solidFill>
           <a:ln>
-            <a:solidFill>
-              <a:srgbClr val="BFBFBF"/>
-            </a:solidFill>
+            <a:noFill/>
           </a:ln>
         </p:spPr>
         <p:style>
@@ -3587,14 +4294,14 @@
       </p:sp>
       <p:sp>
         <p:nvSpPr>
-          <p:cNvPr id="7" name="TextBox 6"/>
+          <p:cNvPr id="8" name="TextBox 7"/>
           <p:cNvSpPr txBox="1"/>
           <p:nvPr/>
         </p:nvSpPr>
         <p:spPr>
           <a:xfrm>
-            <a:off x="4754880" y="1965960"/>
-            <a:ext cx="7132320" cy="457200"/>
+            <a:off x="457200" y="6272784"/>
+            <a:ext cx="11338560" cy="420624"/>
           </a:xfrm>
           <a:prstGeom prst="rect">
             <a:avLst/>
@@ -3602,132 +4309,18 @@
           <a:noFill/>
         </p:spPr>
         <p:txBody>
-          <a:bodyPr wrap="none">
+          <a:bodyPr wrap="square">
             <a:spAutoFit/>
           </a:bodyPr>
           <a:lstStyle/>
           <a:p>
-            <a:pPr algn="ctr"/>
-            <a:r>
-              <a:rPr sz="1100" b="0">
+            <a:r>
+              <a:rPr sz="1200">
                 <a:solidFill>
-                  <a:srgbClr val="808080"/>
+                  <a:srgbClr val="252525"/>
                 </a:solidFill>
               </a:rPr>
-              <a:t>← ここにスクリーンショットを貼付</a:t>
-            </a:r>
-          </a:p>
-        </p:txBody>
-      </p:sp>
-      <p:sp>
-        <p:nvSpPr>
-          <p:cNvPr id="8" name="TextBox 7"/>
-          <p:cNvSpPr txBox="1"/>
-          <p:nvPr/>
-        </p:nvSpPr>
-        <p:spPr>
-          <a:xfrm>
-            <a:off x="4754880" y="3474720"/>
-            <a:ext cx="7132320" cy="347472"/>
-          </a:xfrm>
-          <a:prstGeom prst="rect">
-            <a:avLst/>
-          </a:prstGeom>
-          <a:noFill/>
-        </p:spPr>
-        <p:txBody>
-          <a:bodyPr wrap="none">
-            <a:spAutoFit/>
-          </a:bodyPr>
-          <a:lstStyle/>
-          <a:p>
-            <a:pPr algn="l"/>
-            <a:r>
-              <a:rPr sz="1100" b="1">
-                <a:solidFill>
-                  <a:srgbClr val="1F497D"/>
-                </a:solidFill>
-              </a:rPr>
-              <a:t>4月　変動履歴スクリーンショット（デイズ S）</a:t>
-            </a:r>
-          </a:p>
-        </p:txBody>
-      </p:sp>
-      <p:sp>
-        <p:nvSpPr>
-          <p:cNvPr id="9" name="Rectangle 8"/>
-          <p:cNvSpPr/>
-          <p:nvPr/>
-        </p:nvSpPr>
-        <p:spPr>
-          <a:xfrm>
-            <a:off x="4754880" y="3840480"/>
-            <a:ext cx="7132320" cy="2514600"/>
-          </a:xfrm>
-          <a:prstGeom prst="rect">
-            <a:avLst/>
-          </a:prstGeom>
-          <a:solidFill>
-            <a:srgbClr val="F2F2F2"/>
-          </a:solidFill>
-          <a:ln>
-            <a:solidFill>
-              <a:srgbClr val="BFBFBF"/>
-            </a:solidFill>
-          </a:ln>
-        </p:spPr>
-        <p:style>
-          <a:lnRef idx="1">
-            <a:schemeClr val="accent1"/>
-          </a:lnRef>
-          <a:fillRef idx="3">
-            <a:schemeClr val="accent1"/>
-          </a:fillRef>
-          <a:effectRef idx="2">
-            <a:schemeClr val="accent1"/>
-          </a:effectRef>
-          <a:fontRef idx="minor">
-            <a:schemeClr val="lt1"/>
-          </a:fontRef>
-        </p:style>
-        <p:txBody>
-          <a:bodyPr rtlCol="0" anchor="ctr"/>
-          <a:lstStyle/>
-          <a:p>
-            <a:pPr algn="ctr"/>
-          </a:p>
-        </p:txBody>
-      </p:sp>
-      <p:sp>
-        <p:nvSpPr>
-          <p:cNvPr id="10" name="TextBox 9"/>
-          <p:cNvSpPr txBox="1"/>
-          <p:nvPr/>
-        </p:nvSpPr>
-        <p:spPr>
-          <a:xfrm>
-            <a:off x="4754880" y="4846320"/>
-            <a:ext cx="7132320" cy="457200"/>
-          </a:xfrm>
-          <a:prstGeom prst="rect">
-            <a:avLst/>
-          </a:prstGeom>
-          <a:noFill/>
-        </p:spPr>
-        <p:txBody>
-          <a:bodyPr wrap="none">
-            <a:spAutoFit/>
-          </a:bodyPr>
-          <a:lstStyle/>
-          <a:p>
-            <a:pPr algn="ctr"/>
-            <a:r>
-              <a:rPr sz="1100" b="0">
-                <a:solidFill>
-                  <a:srgbClr val="808080"/>
-                </a:solidFill>
-              </a:rPr>
-              <a:t>← ここにスクリーンショットを貼付</a:t>
+              <a:t>✅  TP設定により、2026年3月分で 1,192回 の価格変動を自動実行し、機会損失の防止と収益最大化に寄与。</a:t>
             </a:r>
           </a:p>
         </p:txBody>
@@ -3765,7 +4358,7 @@
             <a:avLst/>
           </a:prstGeom>
           <a:solidFill>
-            <a:srgbClr val="1F497D"/>
+            <a:srgbClr val="1F3864"/>
           </a:solidFill>
           <a:ln>
             <a:noFill/>
@@ -3801,8 +4394,8 @@
         </p:nvSpPr>
         <p:spPr>
           <a:xfrm>
-            <a:off x="274320" y="91440"/>
-            <a:ext cx="11612880" cy="411480"/>
+            <a:off x="320040" y="91440"/>
+            <a:ext cx="11521440" cy="411480"/>
           </a:xfrm>
           <a:prstGeom prst="rect">
             <a:avLst/>
@@ -3815,13 +4408,14 @@
           </a:bodyPr>
           <a:lstStyle/>
           <a:p>
-            <a:r>
-              <a:rPr sz="1800" b="1">
+            <a:pPr algn="ctr"/>
+            <a:r>
+              <a:rPr sz="2000" b="1">
                 <a:solidFill>
                   <a:srgbClr val="FFFFFF"/>
                 </a:solidFill>
               </a:rPr>
-              <a:t>まとめ・所感</a:t>
+              <a:t>変動履歴対象年月：2026年4月</a:t>
             </a:r>
           </a:p>
         </p:txBody>
@@ -3834,8 +4428,42 @@
         </p:nvSpPr>
         <p:spPr>
           <a:xfrm>
-            <a:off x="731520" y="749808"/>
-            <a:ext cx="10515600" cy="384048"/>
+            <a:off x="365760" y="594360"/>
+            <a:ext cx="2286000" cy="777240"/>
+          </a:xfrm>
+          <a:prstGeom prst="rect">
+            <a:avLst/>
+          </a:prstGeom>
+          <a:noFill/>
+        </p:spPr>
+        <p:txBody>
+          <a:bodyPr wrap="none">
+            <a:spAutoFit/>
+          </a:bodyPr>
+          <a:lstStyle/>
+          <a:p>
+            <a:pPr algn="l"/>
+            <a:r>
+              <a:rPr sz="4200" b="1">
+                <a:solidFill>
+                  <a:srgbClr val="1F3864"/>
+                </a:solidFill>
+              </a:rPr>
+              <a:t>685回</a:t>
+            </a:r>
+          </a:p>
+        </p:txBody>
+      </p:sp>
+      <p:sp>
+        <p:nvSpPr>
+          <p:cNvPr id="5" name="TextBox 4"/>
+          <p:cNvSpPr txBox="1"/>
+          <p:nvPr/>
+        </p:nvSpPr>
+        <p:spPr>
+          <a:xfrm>
+            <a:off x="2651760" y="640080"/>
+            <a:ext cx="4572000" cy="685800"/>
           </a:xfrm>
           <a:prstGeom prst="rect">
             <a:avLst/>
@@ -3850,26 +4478,94 @@
           <a:p>
             <a:pPr algn="l"/>
             <a:r>
-              <a:rPr sz="1400" b="1">
+              <a:rPr sz="900" b="0">
                 <a:solidFill>
-                  <a:srgbClr val="1F497D"/>
+                  <a:srgbClr val="707070"/>
                 </a:solidFill>
               </a:rPr>
-              <a:t>【OCC / ADR / RevPAR】</a:t>
-            </a:r>
-          </a:p>
-        </p:txBody>
-      </p:sp>
-      <p:sp>
-        <p:nvSpPr>
-          <p:cNvPr id="5" name="TextBox 4"/>
+              <a:t>※集計期間：2026年1月〜4月
+※対象部屋：デイズ S（全OTAチャネル合計）</a:t>
+            </a:r>
+          </a:p>
+        </p:txBody>
+      </p:sp>
+      <p:pic>
+        <p:nvPicPr>
+          <p:cNvPr id="6" name="Picture 5" descr="image.png"/>
+          <p:cNvPicPr>
+            <a:picLocks noChangeAspect="1"/>
+          </p:cNvPicPr>
+          <p:nvPr/>
+        </p:nvPicPr>
+        <p:blipFill>
+          <a:blip r:embed="rId2"/>
+          <a:stretch>
+            <a:fillRect/>
+          </a:stretch>
+        </p:blipFill>
+        <p:spPr>
+          <a:xfrm>
+            <a:off x="182880" y="1371600"/>
+            <a:ext cx="11795760" cy="4663440"/>
+          </a:xfrm>
+          <a:prstGeom prst="rect">
+            <a:avLst/>
+          </a:prstGeom>
+        </p:spPr>
+      </p:pic>
+      <p:sp>
+        <p:nvSpPr>
+          <p:cNvPr id="7" name="Rectangle 6"/>
+          <p:cNvSpPr/>
+          <p:nvPr/>
+        </p:nvSpPr>
+        <p:spPr>
+          <a:xfrm>
+            <a:off x="274320" y="6199632"/>
+            <a:ext cx="11612880" cy="530352"/>
+          </a:xfrm>
+          <a:prstGeom prst="rect">
+            <a:avLst/>
+          </a:prstGeom>
+          <a:solidFill>
+            <a:srgbClr val="D6E4F0"/>
+          </a:solidFill>
+          <a:ln>
+            <a:noFill/>
+          </a:ln>
+        </p:spPr>
+        <p:style>
+          <a:lnRef idx="1">
+            <a:schemeClr val="accent1"/>
+          </a:lnRef>
+          <a:fillRef idx="3">
+            <a:schemeClr val="accent1"/>
+          </a:fillRef>
+          <a:effectRef idx="2">
+            <a:schemeClr val="accent1"/>
+          </a:effectRef>
+          <a:fontRef idx="minor">
+            <a:schemeClr val="lt1"/>
+          </a:fontRef>
+        </p:style>
+        <p:txBody>
+          <a:bodyPr rtlCol="0" anchor="ctr"/>
+          <a:lstStyle/>
+          <a:p>
+            <a:pPr algn="ctr"/>
+          </a:p>
+        </p:txBody>
+      </p:sp>
+      <p:sp>
+        <p:nvSpPr>
+          <p:cNvPr id="8" name="TextBox 7"/>
           <p:cNvSpPr txBox="1"/>
           <p:nvPr/>
         </p:nvSpPr>
         <p:spPr>
           <a:xfrm>
-            <a:off x="914400" y="1152144"/>
-            <a:ext cx="10332720" cy="384048"/>
+            <a:off x="457200" y="6272784"/>
+            <a:ext cx="11338560" cy="420624"/>
           </a:xfrm>
           <a:prstGeom prst="rect">
             <a:avLst/>
@@ -3882,28 +4578,764 @@
           </a:bodyPr>
           <a:lstStyle/>
           <a:p>
-            <a:pPr algn="l"/>
-            <a:r>
-              <a:rPr sz="1300" b="0">
+            <a:r>
+              <a:rPr sz="1200">
                 <a:solidFill>
-                  <a:srgbClr val="404040"/>
+                  <a:srgbClr val="252525"/>
                 </a:solidFill>
               </a:rPr>
-              <a:t>・</a:t>
-            </a:r>
-          </a:p>
-        </p:txBody>
-      </p:sp>
-      <p:sp>
-        <p:nvSpPr>
-          <p:cNvPr id="6" name="TextBox 5"/>
+              <a:t>✅  TP設定により、2026年4月分で 685回 の価格変動を自動実行し、機会損失の防止と収益最大化に寄与。</a:t>
+            </a:r>
+          </a:p>
+        </p:txBody>
+      </p:sp>
+    </p:spTree>
+  </p:cSld>
+  <p:clrMapOvr>
+    <a:masterClrMapping/>
+  </p:clrMapOvr>
+</p:sld>
+</file>
+
+<file path=ppt/slides/slide5.xml><?xml version="1.0" encoding="utf-8"?>
+<p:sld xmlns:a="http://schemas.openxmlformats.org/drawingml/2006/main" xmlns:p="http://schemas.openxmlformats.org/presentationml/2006/main" xmlns:r="http://schemas.openxmlformats.org/officeDocument/2006/relationships">
+  <p:cSld>
+    <p:spTree>
+      <p:nvGrpSpPr>
+        <p:cNvPr id="1" name=""/>
+        <p:cNvGrpSpPr/>
+        <p:nvPr/>
+      </p:nvGrpSpPr>
+      <p:grpSpPr/>
+      <p:sp>
+        <p:nvSpPr>
+          <p:cNvPr id="2" name="Rectangle 1"/>
+          <p:cNvSpPr/>
+          <p:nvPr/>
+        </p:nvSpPr>
+        <p:spPr>
+          <a:xfrm>
+            <a:off x="0" y="0"/>
+            <a:ext cx="12188952" cy="6858000"/>
+          </a:xfrm>
+          <a:prstGeom prst="rect">
+            <a:avLst/>
+          </a:prstGeom>
+          <a:solidFill>
+            <a:srgbClr val="1F6BBF"/>
+          </a:solidFill>
+          <a:ln>
+            <a:noFill/>
+          </a:ln>
+        </p:spPr>
+        <p:style>
+          <a:lnRef idx="1">
+            <a:schemeClr val="accent1"/>
+          </a:lnRef>
+          <a:fillRef idx="3">
+            <a:schemeClr val="accent1"/>
+          </a:fillRef>
+          <a:effectRef idx="2">
+            <a:schemeClr val="accent1"/>
+          </a:effectRef>
+          <a:fontRef idx="minor">
+            <a:schemeClr val="lt1"/>
+          </a:fontRef>
+        </p:style>
+        <p:txBody>
+          <a:bodyPr rtlCol="0" anchor="ctr"/>
+          <a:lstStyle/>
+          <a:p>
+            <a:pPr algn="ctr"/>
+          </a:p>
+        </p:txBody>
+      </p:sp>
+      <p:sp>
+        <p:nvSpPr>
+          <p:cNvPr id="3" name="TextBox 2"/>
           <p:cNvSpPr txBox="1"/>
           <p:nvPr/>
         </p:nvSpPr>
         <p:spPr>
           <a:xfrm>
-            <a:off x="914400" y="1554480"/>
-            <a:ext cx="10332720" cy="384048"/>
+            <a:off x="1828800" y="2560320"/>
+            <a:ext cx="8531352" cy="1371600"/>
+          </a:xfrm>
+          <a:prstGeom prst="rect">
+            <a:avLst/>
+          </a:prstGeom>
+          <a:noFill/>
+        </p:spPr>
+        <p:txBody>
+          <a:bodyPr wrap="none">
+            <a:spAutoFit/>
+          </a:bodyPr>
+          <a:lstStyle/>
+          <a:p>
+            <a:pPr algn="ctr"/>
+            <a:r>
+              <a:rPr sz="4000" b="1">
+                <a:solidFill>
+                  <a:srgbClr val="FFFFFF"/>
+                </a:solidFill>
+              </a:rPr>
+              <a:t>昨対比較</a:t>
+            </a:r>
+          </a:p>
+        </p:txBody>
+      </p:sp>
+      <p:sp>
+        <p:nvSpPr>
+          <p:cNvPr id="4" name="TextBox 3"/>
+          <p:cNvSpPr txBox="1"/>
+          <p:nvPr/>
+        </p:nvSpPr>
+        <p:spPr>
+          <a:xfrm>
+            <a:off x="4114800" y="4114800"/>
+            <a:ext cx="3931920" cy="548640"/>
+          </a:xfrm>
+          <a:prstGeom prst="rect">
+            <a:avLst/>
+          </a:prstGeom>
+          <a:noFill/>
+        </p:spPr>
+        <p:txBody>
+          <a:bodyPr wrap="none">
+            <a:spAutoFit/>
+          </a:bodyPr>
+          <a:lstStyle/>
+          <a:p>
+            <a:pPr algn="ctr"/>
+            <a:r>
+              <a:rPr sz="1400" b="0">
+                <a:solidFill>
+                  <a:srgbClr val="FFFFFF"/>
+                </a:solidFill>
+              </a:rPr>
+              <a:t>⬤⬤⬤  TEMAIRAZU</a:t>
+            </a:r>
+          </a:p>
+        </p:txBody>
+      </p:sp>
+    </p:spTree>
+  </p:cSld>
+  <p:clrMapOvr>
+    <a:masterClrMapping/>
+  </p:clrMapOvr>
+</p:sld>
+</file>
+
+<file path=ppt/slides/slide6.xml><?xml version="1.0" encoding="utf-8"?>
+<p:sld xmlns:a="http://schemas.openxmlformats.org/drawingml/2006/main" xmlns:p="http://schemas.openxmlformats.org/presentationml/2006/main" xmlns:r="http://schemas.openxmlformats.org/officeDocument/2006/relationships">
+  <p:cSld>
+    <p:spTree>
+      <p:nvGrpSpPr>
+        <p:cNvPr id="1" name=""/>
+        <p:cNvGrpSpPr/>
+        <p:nvPr/>
+      </p:nvGrpSpPr>
+      <p:grpSpPr/>
+      <p:sp>
+        <p:nvSpPr>
+          <p:cNvPr id="2" name="Rectangle 1"/>
+          <p:cNvSpPr/>
+          <p:nvPr/>
+        </p:nvSpPr>
+        <p:spPr>
+          <a:xfrm>
+            <a:off x="0" y="0"/>
+            <a:ext cx="12188952" cy="548640"/>
+          </a:xfrm>
+          <a:prstGeom prst="rect">
+            <a:avLst/>
+          </a:prstGeom>
+          <a:solidFill>
+            <a:srgbClr val="1F3864"/>
+          </a:solidFill>
+          <a:ln>
+            <a:noFill/>
+          </a:ln>
+        </p:spPr>
+        <p:style>
+          <a:lnRef idx="1">
+            <a:schemeClr val="accent1"/>
+          </a:lnRef>
+          <a:fillRef idx="3">
+            <a:schemeClr val="accent1"/>
+          </a:fillRef>
+          <a:effectRef idx="2">
+            <a:schemeClr val="accent1"/>
+          </a:effectRef>
+          <a:fontRef idx="minor">
+            <a:schemeClr val="lt1"/>
+          </a:fontRef>
+        </p:style>
+        <p:txBody>
+          <a:bodyPr rtlCol="0" anchor="ctr"/>
+          <a:lstStyle/>
+          <a:p>
+            <a:pPr algn="ctr"/>
+          </a:p>
+        </p:txBody>
+      </p:sp>
+      <p:sp>
+        <p:nvSpPr>
+          <p:cNvPr id="3" name="TextBox 2"/>
+          <p:cNvSpPr txBox="1"/>
+          <p:nvPr/>
+        </p:nvSpPr>
+        <p:spPr>
+          <a:xfrm>
+            <a:off x="320040" y="91440"/>
+            <a:ext cx="11521440" cy="411480"/>
+          </a:xfrm>
+          <a:prstGeom prst="rect">
+            <a:avLst/>
+          </a:prstGeom>
+          <a:noFill/>
+        </p:spPr>
+        <p:txBody>
+          <a:bodyPr wrap="none">
+            <a:spAutoFit/>
+          </a:bodyPr>
+          <a:lstStyle/>
+          <a:p>
+            <a:pPr algn="ctr"/>
+            <a:r>
+              <a:rPr sz="2000" b="1">
+                <a:solidFill>
+                  <a:srgbClr val="FFFFFF"/>
+                </a:solidFill>
+              </a:rPr>
+              <a:t>月次実績比較（チェックイン日ベース　2025年 vs 2026年）</a:t>
+            </a:r>
+          </a:p>
+        </p:txBody>
+      </p:sp>
+      <p:graphicFrame>
+        <p:nvGraphicFramePr>
+          <p:cNvPr id="4" name="Table 3"/>
+          <p:cNvGraphicFramePr>
+            <a:graphicFrameLocks noGrp="1"/>
+          </p:cNvGraphicFramePr>
+          <p:nvPr/>
+        </p:nvGraphicFramePr>
+        <p:xfrm>
+          <a:off x="274320" y="731520"/>
+          <a:ext cx="4069080" cy="4572000"/>
+        </p:xfrm>
+        <a:graphic>
+          <a:graphicData uri="http://schemas.openxmlformats.org/drawingml/2006/table">
+            <a:tbl>
+              <a:tblPr firstRow="1" bandRow="1">
+                <a:tableStyleId>{5C22544A-7EE6-4342-B048-85BDC9FD1C3A}</a:tableStyleId>
+              </a:tblPr>
+              <a:tblGrid>
+                <a:gridCol w="1188720"/>
+                <a:gridCol w="960120"/>
+                <a:gridCol w="960120"/>
+                <a:gridCol w="960120"/>
+              </a:tblGrid>
+              <a:tr h="914400">
+                <a:tc>
+                  <a:txBody>
+                    <a:bodyPr wrap="none"/>
+                    <a:lstStyle/>
+                    <a:p>
+                      <a:pPr algn="ctr"/>
+                      <a:r>
+                        <a:rPr sz="1000" b="1">
+                          <a:solidFill>
+                            <a:srgbClr val="FFFFFF"/>
+                          </a:solidFill>
+                        </a:rPr>
+                        <a:t>指標</a:t>
+                      </a:r>
+                    </a:p>
+                  </a:txBody>
+                  <a:tcPr>
+                    <a:solidFill>
+                      <a:srgbClr val="1F3864"/>
+                    </a:solidFill>
+                  </a:tcPr>
+                </a:tc>
+                <a:tc>
+                  <a:txBody>
+                    <a:bodyPr wrap="none"/>
+                    <a:lstStyle/>
+                    <a:p>
+                      <a:pPr algn="ctr"/>
+                      <a:r>
+                        <a:rPr sz="1000" b="1">
+                          <a:solidFill>
+                            <a:srgbClr val="FFFFFF"/>
+                          </a:solidFill>
+                        </a:rPr>
+                        <a:t>2025年</a:t>
+                      </a:r>
+                    </a:p>
+                  </a:txBody>
+                  <a:tcPr>
+                    <a:solidFill>
+                      <a:srgbClr val="1F3864"/>
+                    </a:solidFill>
+                  </a:tcPr>
+                </a:tc>
+                <a:tc>
+                  <a:txBody>
+                    <a:bodyPr wrap="none"/>
+                    <a:lstStyle/>
+                    <a:p>
+                      <a:pPr algn="ctr"/>
+                      <a:r>
+                        <a:rPr sz="1000" b="1">
+                          <a:solidFill>
+                            <a:srgbClr val="FFFFFF"/>
+                          </a:solidFill>
+                        </a:rPr>
+                        <a:t>2026年</a:t>
+                      </a:r>
+                    </a:p>
+                  </a:txBody>
+                  <a:tcPr>
+                    <a:solidFill>
+                      <a:srgbClr val="1F3864"/>
+                    </a:solidFill>
+                  </a:tcPr>
+                </a:tc>
+                <a:tc>
+                  <a:txBody>
+                    <a:bodyPr wrap="none"/>
+                    <a:lstStyle/>
+                    <a:p>
+                      <a:pPr algn="ctr"/>
+                      <a:r>
+                        <a:rPr sz="1000" b="1">
+                          <a:solidFill>
+                            <a:srgbClr val="FFFFFF"/>
+                          </a:solidFill>
+                        </a:rPr>
+                        <a:t>増減</a:t>
+                      </a:r>
+                    </a:p>
+                  </a:txBody>
+                  <a:tcPr>
+                    <a:solidFill>
+                      <a:srgbClr val="1F3864"/>
+                    </a:solidFill>
+                  </a:tcPr>
+                </a:tc>
+              </a:tr>
+              <a:tr h="914400">
+                <a:tc>
+                  <a:txBody>
+                    <a:bodyPr wrap="none"/>
+                    <a:lstStyle/>
+                    <a:p>
+                      <a:pPr algn="ctr"/>
+                      <a:r>
+                        <a:rPr sz="1000" b="1">
+                          <a:solidFill>
+                            <a:srgbClr val="252525"/>
+                          </a:solidFill>
+                        </a:rPr>
+                        <a:t>OCC（%）</a:t>
+                      </a:r>
+                    </a:p>
+                  </a:txBody>
+                  <a:tcPr/>
+                </a:tc>
+                <a:tc>
+                  <a:txBody>
+                    <a:bodyPr wrap="none"/>
+                    <a:lstStyle/>
+                    <a:p>
+                      <a:pPr algn="ctr"/>
+                      <a:r>
+                        <a:rPr sz="1000" b="0">
+                          <a:solidFill>
+                            <a:srgbClr val="252525"/>
+                          </a:solidFill>
+                        </a:rPr>
+                        <a:t>67.1%</a:t>
+                      </a:r>
+                    </a:p>
+                  </a:txBody>
+                  <a:tcPr/>
+                </a:tc>
+                <a:tc>
+                  <a:txBody>
+                    <a:bodyPr wrap="none"/>
+                    <a:lstStyle/>
+                    <a:p>
+                      <a:pPr algn="ctr"/>
+                      <a:r>
+                        <a:rPr sz="1000" b="0">
+                          <a:solidFill>
+                            <a:srgbClr val="252525"/>
+                          </a:solidFill>
+                        </a:rPr>
+                        <a:t>60.2%</a:t>
+                      </a:r>
+                    </a:p>
+                  </a:txBody>
+                  <a:tcPr/>
+                </a:tc>
+                <a:tc>
+                  <a:txBody>
+                    <a:bodyPr wrap="none"/>
+                    <a:lstStyle/>
+                    <a:p>
+                      <a:pPr algn="ctr"/>
+                      <a:r>
+                        <a:rPr sz="1000" b="0">
+                          <a:solidFill>
+                            <a:srgbClr val="252525"/>
+                          </a:solidFill>
+                        </a:rPr>
+                        <a:t>-6.9pt</a:t>
+                      </a:r>
+                    </a:p>
+                  </a:txBody>
+                  <a:tcPr/>
+                </a:tc>
+              </a:tr>
+              <a:tr h="914400">
+                <a:tc>
+                  <a:txBody>
+                    <a:bodyPr wrap="none"/>
+                    <a:lstStyle/>
+                    <a:p>
+                      <a:pPr algn="ctr"/>
+                      <a:r>
+                        <a:rPr sz="1000" b="1">
+                          <a:solidFill>
+                            <a:srgbClr val="252525"/>
+                          </a:solidFill>
+                        </a:rPr>
+                        <a:t>ADR（円）</a:t>
+                      </a:r>
+                    </a:p>
+                  </a:txBody>
+                  <a:tcPr>
+                    <a:solidFill>
+                      <a:srgbClr val="BDD7EE"/>
+                    </a:solidFill>
+                  </a:tcPr>
+                </a:tc>
+                <a:tc>
+                  <a:txBody>
+                    <a:bodyPr wrap="none"/>
+                    <a:lstStyle/>
+                    <a:p>
+                      <a:pPr algn="ctr"/>
+                      <a:r>
+                        <a:rPr sz="1000" b="0">
+                          <a:solidFill>
+                            <a:srgbClr val="252525"/>
+                          </a:solidFill>
+                        </a:rPr>
+                        <a:t>¥8,668</a:t>
+                      </a:r>
+                    </a:p>
+                  </a:txBody>
+                  <a:tcPr>
+                    <a:solidFill>
+                      <a:srgbClr val="BDD7EE"/>
+                    </a:solidFill>
+                  </a:tcPr>
+                </a:tc>
+                <a:tc>
+                  <a:txBody>
+                    <a:bodyPr wrap="none"/>
+                    <a:lstStyle/>
+                    <a:p>
+                      <a:pPr algn="ctr"/>
+                      <a:r>
+                        <a:rPr sz="1000" b="0">
+                          <a:solidFill>
+                            <a:srgbClr val="252525"/>
+                          </a:solidFill>
+                        </a:rPr>
+                        <a:t>¥9,559</a:t>
+                      </a:r>
+                    </a:p>
+                  </a:txBody>
+                  <a:tcPr>
+                    <a:solidFill>
+                      <a:srgbClr val="BDD7EE"/>
+                    </a:solidFill>
+                  </a:tcPr>
+                </a:tc>
+                <a:tc>
+                  <a:txBody>
+                    <a:bodyPr wrap="none"/>
+                    <a:lstStyle/>
+                    <a:p>
+                      <a:pPr algn="ctr"/>
+                      <a:r>
+                        <a:rPr sz="1000" b="0">
+                          <a:solidFill>
+                            <a:srgbClr val="C00000"/>
+                          </a:solidFill>
+                        </a:rPr>
+                        <a:t>+891円</a:t>
+                      </a:r>
+                    </a:p>
+                  </a:txBody>
+                  <a:tcPr>
+                    <a:solidFill>
+                      <a:srgbClr val="BDD7EE"/>
+                    </a:solidFill>
+                  </a:tcPr>
+                </a:tc>
+              </a:tr>
+              <a:tr h="914400">
+                <a:tc>
+                  <a:txBody>
+                    <a:bodyPr wrap="none"/>
+                    <a:lstStyle/>
+                    <a:p>
+                      <a:pPr algn="ctr"/>
+                      <a:r>
+                        <a:rPr sz="1000" b="1">
+                          <a:solidFill>
+                            <a:srgbClr val="252525"/>
+                          </a:solidFill>
+                        </a:rPr>
+                        <a:t>RevPAR（円）</a:t>
+                      </a:r>
+                    </a:p>
+                  </a:txBody>
+                  <a:tcPr/>
+                </a:tc>
+                <a:tc>
+                  <a:txBody>
+                    <a:bodyPr wrap="none"/>
+                    <a:lstStyle/>
+                    <a:p>
+                      <a:pPr algn="ctr"/>
+                      <a:r>
+                        <a:rPr sz="1000" b="0">
+                          <a:solidFill>
+                            <a:srgbClr val="252525"/>
+                          </a:solidFill>
+                        </a:rPr>
+                        <a:t>¥5,820</a:t>
+                      </a:r>
+                    </a:p>
+                  </a:txBody>
+                  <a:tcPr/>
+                </a:tc>
+                <a:tc>
+                  <a:txBody>
+                    <a:bodyPr wrap="none"/>
+                    <a:lstStyle/>
+                    <a:p>
+                      <a:pPr algn="ctr"/>
+                      <a:r>
+                        <a:rPr sz="1000" b="0">
+                          <a:solidFill>
+                            <a:srgbClr val="252525"/>
+                          </a:solidFill>
+                        </a:rPr>
+                        <a:t>¥5,744</a:t>
+                      </a:r>
+                    </a:p>
+                  </a:txBody>
+                  <a:tcPr/>
+                </a:tc>
+                <a:tc>
+                  <a:txBody>
+                    <a:bodyPr wrap="none"/>
+                    <a:lstStyle/>
+                    <a:p>
+                      <a:pPr algn="ctr"/>
+                      <a:r>
+                        <a:rPr sz="1000" b="0">
+                          <a:solidFill>
+                            <a:srgbClr val="252525"/>
+                          </a:solidFill>
+                        </a:rPr>
+                        <a:t>-76円</a:t>
+                      </a:r>
+                    </a:p>
+                  </a:txBody>
+                  <a:tcPr/>
+                </a:tc>
+              </a:tr>
+              <a:tr h="914400">
+                <a:tc>
+                  <a:txBody>
+                    <a:bodyPr wrap="none"/>
+                    <a:lstStyle/>
+                    <a:p>
+                      <a:pPr algn="ctr"/>
+                      <a:r>
+                        <a:rPr sz="1000" b="1">
+                          <a:solidFill>
+                            <a:srgbClr val="252525"/>
+                          </a:solidFill>
+                        </a:rPr>
+                        <a:t>売上（円）</a:t>
+                      </a:r>
+                    </a:p>
+                  </a:txBody>
+                  <a:tcPr>
+                    <a:solidFill>
+                      <a:srgbClr val="BDD7EE"/>
+                    </a:solidFill>
+                  </a:tcPr>
+                </a:tc>
+                <a:tc>
+                  <a:txBody>
+                    <a:bodyPr wrap="none"/>
+                    <a:lstStyle/>
+                    <a:p>
+                      <a:pPr algn="ctr"/>
+                      <a:r>
+                        <a:rPr sz="1000" b="0">
+                          <a:solidFill>
+                            <a:srgbClr val="252525"/>
+                          </a:solidFill>
+                        </a:rPr>
+                        <a:t>¥41,458,787</a:t>
+                      </a:r>
+                    </a:p>
+                  </a:txBody>
+                  <a:tcPr>
+                    <a:solidFill>
+                      <a:srgbClr val="BDD7EE"/>
+                    </a:solidFill>
+                  </a:tcPr>
+                </a:tc>
+                <a:tc>
+                  <a:txBody>
+                    <a:bodyPr wrap="none"/>
+                    <a:lstStyle/>
+                    <a:p>
+                      <a:pPr algn="ctr"/>
+                      <a:r>
+                        <a:rPr sz="1000" b="0">
+                          <a:solidFill>
+                            <a:srgbClr val="252525"/>
+                          </a:solidFill>
+                        </a:rPr>
+                        <a:t>¥40,978,117</a:t>
+                      </a:r>
+                    </a:p>
+                  </a:txBody>
+                  <a:tcPr>
+                    <a:solidFill>
+                      <a:srgbClr val="BDD7EE"/>
+                    </a:solidFill>
+                  </a:tcPr>
+                </a:tc>
+                <a:tc>
+                  <a:txBody>
+                    <a:bodyPr wrap="none"/>
+                    <a:lstStyle/>
+                    <a:p>
+                      <a:pPr algn="ctr"/>
+                      <a:r>
+                        <a:rPr sz="1000" b="0">
+                          <a:solidFill>
+                            <a:srgbClr val="252525"/>
+                          </a:solidFill>
+                        </a:rPr>
+                        <a:t>-480,670円</a:t>
+                      </a:r>
+                    </a:p>
+                  </a:txBody>
+                  <a:tcPr>
+                    <a:solidFill>
+                      <a:srgbClr val="BDD7EE"/>
+                    </a:solidFill>
+                  </a:tcPr>
+                </a:tc>
+              </a:tr>
+            </a:tbl>
+          </a:graphicData>
+        </a:graphic>
+      </p:graphicFrame>
+      <p:pic>
+        <p:nvPicPr>
+          <p:cNvPr id="5" name="Picture 4" descr="image.png"/>
+          <p:cNvPicPr>
+            <a:picLocks noChangeAspect="1"/>
+          </p:cNvPicPr>
+          <p:nvPr/>
+        </p:nvPicPr>
+        <p:blipFill>
+          <a:blip r:embed="rId2"/>
+          <a:stretch>
+            <a:fillRect/>
+          </a:stretch>
+        </p:blipFill>
+        <p:spPr>
+          <a:xfrm>
+            <a:off x="4480560" y="685800"/>
+            <a:ext cx="7498079" cy="5943600"/>
+          </a:xfrm>
+          <a:prstGeom prst="rect">
+            <a:avLst/>
+          </a:prstGeom>
+        </p:spPr>
+      </p:pic>
+      <p:sp>
+        <p:nvSpPr>
+          <p:cNvPr id="6" name="Rectangle 5"/>
+          <p:cNvSpPr/>
+          <p:nvPr/>
+        </p:nvSpPr>
+        <p:spPr>
+          <a:xfrm>
+            <a:off x="274320" y="5577840"/>
+            <a:ext cx="4023360" cy="594360"/>
+          </a:xfrm>
+          <a:prstGeom prst="rect">
+            <a:avLst/>
+          </a:prstGeom>
+          <a:solidFill>
+            <a:srgbClr val="D6E4F0"/>
+          </a:solidFill>
+          <a:ln>
+            <a:noFill/>
+          </a:ln>
+        </p:spPr>
+        <p:style>
+          <a:lnRef idx="1">
+            <a:schemeClr val="accent1"/>
+          </a:lnRef>
+          <a:fillRef idx="3">
+            <a:schemeClr val="accent1"/>
+          </a:fillRef>
+          <a:effectRef idx="2">
+            <a:schemeClr val="accent1"/>
+          </a:effectRef>
+          <a:fontRef idx="minor">
+            <a:schemeClr val="lt1"/>
+          </a:fontRef>
+        </p:style>
+        <p:txBody>
+          <a:bodyPr rtlCol="0" anchor="ctr"/>
+          <a:lstStyle/>
+          <a:p>
+            <a:pPr algn="ctr"/>
+          </a:p>
+        </p:txBody>
+      </p:sp>
+      <p:sp>
+        <p:nvSpPr>
+          <p:cNvPr id="7" name="TextBox 6"/>
+          <p:cNvSpPr txBox="1"/>
+          <p:nvPr/>
+        </p:nvSpPr>
+        <p:spPr>
+          <a:xfrm>
+            <a:off x="457200" y="5650992"/>
+            <a:ext cx="3749040" cy="484632"/>
           </a:xfrm>
           <a:prstGeom prst="rect">
             <a:avLst/>
@@ -3916,28 +5348,278 @@
           </a:bodyPr>
           <a:lstStyle/>
           <a:p>
-            <a:pPr algn="l"/>
-            <a:r>
-              <a:rPr sz="1300" b="0">
+            <a:r>
+              <a:rPr sz="1200">
                 <a:solidFill>
-                  <a:srgbClr val="404040"/>
+                  <a:srgbClr val="252525"/>
                 </a:solidFill>
               </a:rPr>
-              <a:t>・</a:t>
-            </a:r>
-          </a:p>
-        </p:txBody>
-      </p:sp>
-      <p:sp>
-        <p:nvSpPr>
-          <p:cNvPr id="7" name="TextBox 6"/>
+              <a:t>✅  稼働率はOCC・売上にばらつきがあるものの、ADRは全月で上昇。単価改善が進んでいます。</a:t>
+            </a:r>
+          </a:p>
+        </p:txBody>
+      </p:sp>
+    </p:spTree>
+  </p:cSld>
+  <p:clrMapOvr>
+    <a:masterClrMapping/>
+  </p:clrMapOvr>
+</p:sld>
+</file>
+
+<file path=ppt/slides/slide7.xml><?xml version="1.0" encoding="utf-8"?>
+<p:sld xmlns:a="http://schemas.openxmlformats.org/drawingml/2006/main" xmlns:p="http://schemas.openxmlformats.org/presentationml/2006/main" xmlns:r="http://schemas.openxmlformats.org/officeDocument/2006/relationships">
+  <p:cSld>
+    <p:spTree>
+      <p:nvGrpSpPr>
+        <p:cNvPr id="1" name=""/>
+        <p:cNvGrpSpPr/>
+        <p:nvPr/>
+      </p:nvGrpSpPr>
+      <p:grpSpPr/>
+      <p:sp>
+        <p:nvSpPr>
+          <p:cNvPr id="2" name="Rectangle 1"/>
+          <p:cNvSpPr/>
+          <p:nvPr/>
+        </p:nvSpPr>
+        <p:spPr>
+          <a:xfrm>
+            <a:off x="0" y="0"/>
+            <a:ext cx="12188952" cy="548640"/>
+          </a:xfrm>
+          <a:prstGeom prst="rect">
+            <a:avLst/>
+          </a:prstGeom>
+          <a:solidFill>
+            <a:srgbClr val="1F3864"/>
+          </a:solidFill>
+          <a:ln>
+            <a:noFill/>
+          </a:ln>
+        </p:spPr>
+        <p:style>
+          <a:lnRef idx="1">
+            <a:schemeClr val="accent1"/>
+          </a:lnRef>
+          <a:fillRef idx="3">
+            <a:schemeClr val="accent1"/>
+          </a:fillRef>
+          <a:effectRef idx="2">
+            <a:schemeClr val="accent1"/>
+          </a:effectRef>
+          <a:fontRef idx="minor">
+            <a:schemeClr val="lt1"/>
+          </a:fontRef>
+        </p:style>
+        <p:txBody>
+          <a:bodyPr rtlCol="0" anchor="ctr"/>
+          <a:lstStyle/>
+          <a:p>
+            <a:pPr algn="ctr"/>
+          </a:p>
+        </p:txBody>
+      </p:sp>
+      <p:sp>
+        <p:nvSpPr>
+          <p:cNvPr id="3" name="TextBox 2"/>
           <p:cNvSpPr txBox="1"/>
           <p:nvPr/>
         </p:nvSpPr>
         <p:spPr>
           <a:xfrm>
-            <a:off x="731520" y="2048256"/>
-            <a:ext cx="10515600" cy="384048"/>
+            <a:off x="320040" y="91440"/>
+            <a:ext cx="11521440" cy="411480"/>
+          </a:xfrm>
+          <a:prstGeom prst="rect">
+            <a:avLst/>
+          </a:prstGeom>
+          <a:noFill/>
+        </p:spPr>
+        <p:txBody>
+          <a:bodyPr wrap="none">
+            <a:spAutoFit/>
+          </a:bodyPr>
+          <a:lstStyle/>
+          <a:p>
+            <a:pPr algn="ctr"/>
+            <a:r>
+              <a:rPr sz="2000" b="1">
+                <a:solidFill>
+                  <a:srgbClr val="FFFFFF"/>
+                </a:solidFill>
+              </a:rPr>
+              <a:t>運用変化</a:t>
+            </a:r>
+          </a:p>
+        </p:txBody>
+      </p:sp>
+      <p:sp>
+        <p:nvSpPr>
+          <p:cNvPr id="4" name="Rectangle 3"/>
+          <p:cNvSpPr/>
+          <p:nvPr/>
+        </p:nvSpPr>
+        <p:spPr>
+          <a:xfrm>
+            <a:off x="320040" y="777240"/>
+            <a:ext cx="5394960" cy="4297680"/>
+          </a:xfrm>
+          <a:prstGeom prst="rect">
+            <a:avLst/>
+          </a:prstGeom>
+          <a:solidFill>
+            <a:srgbClr val="F0F5FB"/>
+          </a:solidFill>
+          <a:ln>
+            <a:solidFill>
+              <a:srgbClr val="1F3864"/>
+            </a:solidFill>
+          </a:ln>
+        </p:spPr>
+        <p:style>
+          <a:lnRef idx="1">
+            <a:schemeClr val="accent1"/>
+          </a:lnRef>
+          <a:fillRef idx="3">
+            <a:schemeClr val="accent1"/>
+          </a:fillRef>
+          <a:effectRef idx="2">
+            <a:schemeClr val="accent1"/>
+          </a:effectRef>
+          <a:fontRef idx="minor">
+            <a:schemeClr val="lt1"/>
+          </a:fontRef>
+        </p:style>
+        <p:txBody>
+          <a:bodyPr rtlCol="0" anchor="ctr"/>
+          <a:lstStyle/>
+          <a:p>
+            <a:pPr algn="ctr"/>
+          </a:p>
+        </p:txBody>
+      </p:sp>
+      <p:sp>
+        <p:nvSpPr>
+          <p:cNvPr id="5" name="TextBox 4"/>
+          <p:cNvSpPr txBox="1"/>
+          <p:nvPr/>
+        </p:nvSpPr>
+        <p:spPr>
+          <a:xfrm>
+            <a:off x="457200" y="822960"/>
+            <a:ext cx="5120640" cy="502920"/>
+          </a:xfrm>
+          <a:prstGeom prst="rect">
+            <a:avLst/>
+          </a:prstGeom>
+          <a:noFill/>
+        </p:spPr>
+        <p:txBody>
+          <a:bodyPr wrap="none">
+            <a:spAutoFit/>
+          </a:bodyPr>
+          <a:lstStyle/>
+          <a:p>
+            <a:pPr algn="l"/>
+            <a:r>
+              <a:rPr sz="1400" b="1">
+                <a:solidFill>
+                  <a:srgbClr val="1F3864"/>
+                </a:solidFill>
+              </a:rPr>
+              <a:t>【Before】手動オペレーション中心</a:t>
+            </a:r>
+          </a:p>
+        </p:txBody>
+      </p:sp>
+      <p:sp>
+        <p:nvSpPr>
+          <p:cNvPr id="6" name="TextBox 5"/>
+          <p:cNvSpPr txBox="1"/>
+          <p:nvPr/>
+        </p:nvSpPr>
+        <p:spPr>
+          <a:xfrm>
+            <a:off x="457200" y="1417320"/>
+            <a:ext cx="457200" cy="320040"/>
+          </a:xfrm>
+          <a:prstGeom prst="rect">
+            <a:avLst/>
+          </a:prstGeom>
+          <a:noFill/>
+        </p:spPr>
+        <p:txBody>
+          <a:bodyPr wrap="none">
+            <a:spAutoFit/>
+          </a:bodyPr>
+          <a:lstStyle/>
+          <a:p>
+            <a:pPr algn="l"/>
+            <a:r>
+              <a:rPr sz="1100" b="1">
+                <a:solidFill>
+                  <a:srgbClr val="1F3864"/>
+                </a:solidFill>
+              </a:rPr>
+              <a:t>01</a:t>
+            </a:r>
+          </a:p>
+        </p:txBody>
+      </p:sp>
+      <p:sp>
+        <p:nvSpPr>
+          <p:cNvPr id="7" name="Rectangle 6"/>
+          <p:cNvSpPr/>
+          <p:nvPr/>
+        </p:nvSpPr>
+        <p:spPr>
+          <a:xfrm>
+            <a:off x="457200" y="1755648"/>
+            <a:ext cx="5120640" cy="18288"/>
+          </a:xfrm>
+          <a:prstGeom prst="rect">
+            <a:avLst/>
+          </a:prstGeom>
+          <a:solidFill>
+            <a:srgbClr val="1F3864"/>
+          </a:solidFill>
+          <a:ln>
+            <a:noFill/>
+          </a:ln>
+        </p:spPr>
+        <p:style>
+          <a:lnRef idx="1">
+            <a:schemeClr val="accent1"/>
+          </a:lnRef>
+          <a:fillRef idx="3">
+            <a:schemeClr val="accent1"/>
+          </a:fillRef>
+          <a:effectRef idx="2">
+            <a:schemeClr val="accent1"/>
+          </a:effectRef>
+          <a:fontRef idx="minor">
+            <a:schemeClr val="lt1"/>
+          </a:fontRef>
+        </p:style>
+        <p:txBody>
+          <a:bodyPr rtlCol="0" anchor="ctr"/>
+          <a:lstStyle/>
+          <a:p>
+            <a:pPr algn="ctr"/>
+          </a:p>
+        </p:txBody>
+      </p:sp>
+      <p:sp>
+        <p:nvSpPr>
+          <p:cNvPr id="8" name="TextBox 7"/>
+          <p:cNvSpPr txBox="1"/>
+          <p:nvPr/>
+        </p:nvSpPr>
+        <p:spPr>
+          <a:xfrm>
+            <a:off x="457200" y="1801368"/>
+            <a:ext cx="5120640" cy="457200"/>
           </a:xfrm>
           <a:prstGeom prst="rect">
             <a:avLst/>
@@ -3952,26 +5634,104 @@
           <a:p>
             <a:pPr algn="l"/>
             <a:r>
-              <a:rPr sz="1400" b="1">
+              <a:rPr sz="1100" b="0">
                 <a:solidFill>
-                  <a:srgbClr val="1F497D"/>
+                  <a:srgbClr val="252525"/>
                 </a:solidFill>
               </a:rPr>
-              <a:t>【変動回数】</a:t>
-            </a:r>
-          </a:p>
-        </p:txBody>
-      </p:sp>
-      <p:sp>
-        <p:nvSpPr>
-          <p:cNvPr id="8" name="TextBox 7"/>
+              <a:t>毎朝：直近予約・オンハンド
+確認</a:t>
+            </a:r>
+          </a:p>
+        </p:txBody>
+      </p:sp>
+      <p:sp>
+        <p:nvSpPr>
+          <p:cNvPr id="9" name="TextBox 8"/>
           <p:cNvSpPr txBox="1"/>
           <p:nvPr/>
         </p:nvSpPr>
         <p:spPr>
           <a:xfrm>
-            <a:off x="914400" y="2450592"/>
-            <a:ext cx="10332720" cy="384048"/>
+            <a:off x="457200" y="2286000"/>
+            <a:ext cx="457200" cy="320040"/>
+          </a:xfrm>
+          <a:prstGeom prst="rect">
+            <a:avLst/>
+          </a:prstGeom>
+          <a:noFill/>
+        </p:spPr>
+        <p:txBody>
+          <a:bodyPr wrap="none">
+            <a:spAutoFit/>
+          </a:bodyPr>
+          <a:lstStyle/>
+          <a:p>
+            <a:pPr algn="l"/>
+            <a:r>
+              <a:rPr sz="1100" b="1">
+                <a:solidFill>
+                  <a:srgbClr val="1F3864"/>
+                </a:solidFill>
+              </a:rPr>
+              <a:t>02</a:t>
+            </a:r>
+          </a:p>
+        </p:txBody>
+      </p:sp>
+      <p:sp>
+        <p:nvSpPr>
+          <p:cNvPr id="10" name="Rectangle 9"/>
+          <p:cNvSpPr/>
+          <p:nvPr/>
+        </p:nvSpPr>
+        <p:spPr>
+          <a:xfrm>
+            <a:off x="457200" y="2624328"/>
+            <a:ext cx="5120640" cy="18288"/>
+          </a:xfrm>
+          <a:prstGeom prst="rect">
+            <a:avLst/>
+          </a:prstGeom>
+          <a:solidFill>
+            <a:srgbClr val="1F3864"/>
+          </a:solidFill>
+          <a:ln>
+            <a:noFill/>
+          </a:ln>
+        </p:spPr>
+        <p:style>
+          <a:lnRef idx="1">
+            <a:schemeClr val="accent1"/>
+          </a:lnRef>
+          <a:fillRef idx="3">
+            <a:schemeClr val="accent1"/>
+          </a:fillRef>
+          <a:effectRef idx="2">
+            <a:schemeClr val="accent1"/>
+          </a:effectRef>
+          <a:fontRef idx="minor">
+            <a:schemeClr val="lt1"/>
+          </a:fontRef>
+        </p:style>
+        <p:txBody>
+          <a:bodyPr rtlCol="0" anchor="ctr"/>
+          <a:lstStyle/>
+          <a:p>
+            <a:pPr algn="ctr"/>
+          </a:p>
+        </p:txBody>
+      </p:sp>
+      <p:sp>
+        <p:nvSpPr>
+          <p:cNvPr id="11" name="TextBox 10"/>
+          <p:cNvSpPr txBox="1"/>
+          <p:nvPr/>
+        </p:nvSpPr>
+        <p:spPr>
+          <a:xfrm>
+            <a:off x="457200" y="2670048"/>
+            <a:ext cx="5120640" cy="457200"/>
           </a:xfrm>
           <a:prstGeom prst="rect">
             <a:avLst/>
@@ -3986,26 +5746,104 @@
           <a:p>
             <a:pPr algn="l"/>
             <a:r>
-              <a:rPr sz="1300" b="0">
+              <a:rPr sz="1100" b="0">
                 <a:solidFill>
-                  <a:srgbClr val="404040"/>
+                  <a:srgbClr val="252525"/>
                 </a:solidFill>
               </a:rPr>
-              <a:t>・</a:t>
-            </a:r>
-          </a:p>
-        </p:txBody>
-      </p:sp>
-      <p:sp>
-        <p:nvSpPr>
-          <p:cNvPr id="9" name="TextBox 8"/>
+              <a:t>前日比較で料金調整
+（365日先まで）</a:t>
+            </a:r>
+          </a:p>
+        </p:txBody>
+      </p:sp>
+      <p:sp>
+        <p:nvSpPr>
+          <p:cNvPr id="12" name="TextBox 11"/>
           <p:cNvSpPr txBox="1"/>
           <p:nvPr/>
         </p:nvSpPr>
         <p:spPr>
           <a:xfrm>
-            <a:off x="914400" y="2852928"/>
-            <a:ext cx="10332720" cy="384048"/>
+            <a:off x="457200" y="3154680"/>
+            <a:ext cx="457200" cy="320040"/>
+          </a:xfrm>
+          <a:prstGeom prst="rect">
+            <a:avLst/>
+          </a:prstGeom>
+          <a:noFill/>
+        </p:spPr>
+        <p:txBody>
+          <a:bodyPr wrap="none">
+            <a:spAutoFit/>
+          </a:bodyPr>
+          <a:lstStyle/>
+          <a:p>
+            <a:pPr algn="l"/>
+            <a:r>
+              <a:rPr sz="1100" b="1">
+                <a:solidFill>
+                  <a:srgbClr val="1F3864"/>
+                </a:solidFill>
+              </a:rPr>
+              <a:t>03</a:t>
+            </a:r>
+          </a:p>
+        </p:txBody>
+      </p:sp>
+      <p:sp>
+        <p:nvSpPr>
+          <p:cNvPr id="13" name="Rectangle 12"/>
+          <p:cNvSpPr/>
+          <p:nvPr/>
+        </p:nvSpPr>
+        <p:spPr>
+          <a:xfrm>
+            <a:off x="457200" y="3493008"/>
+            <a:ext cx="5120640" cy="18288"/>
+          </a:xfrm>
+          <a:prstGeom prst="rect">
+            <a:avLst/>
+          </a:prstGeom>
+          <a:solidFill>
+            <a:srgbClr val="1F3864"/>
+          </a:solidFill>
+          <a:ln>
+            <a:noFill/>
+          </a:ln>
+        </p:spPr>
+        <p:style>
+          <a:lnRef idx="1">
+            <a:schemeClr val="accent1"/>
+          </a:lnRef>
+          <a:fillRef idx="3">
+            <a:schemeClr val="accent1"/>
+          </a:fillRef>
+          <a:effectRef idx="2">
+            <a:schemeClr val="accent1"/>
+          </a:effectRef>
+          <a:fontRef idx="minor">
+            <a:schemeClr val="lt1"/>
+          </a:fontRef>
+        </p:style>
+        <p:txBody>
+          <a:bodyPr rtlCol="0" anchor="ctr"/>
+          <a:lstStyle/>
+          <a:p>
+            <a:pPr algn="ctr"/>
+          </a:p>
+        </p:txBody>
+      </p:sp>
+      <p:sp>
+        <p:nvSpPr>
+          <p:cNvPr id="14" name="TextBox 13"/>
+          <p:cNvSpPr txBox="1"/>
+          <p:nvPr/>
+        </p:nvSpPr>
+        <p:spPr>
+          <a:xfrm>
+            <a:off x="457200" y="3538728"/>
+            <a:ext cx="5120640" cy="457200"/>
           </a:xfrm>
           <a:prstGeom prst="rect">
             <a:avLst/>
@@ -4020,26 +5858,103 @@
           <a:p>
             <a:pPr algn="l"/>
             <a:r>
-              <a:rPr sz="1300" b="0">
+              <a:rPr sz="1100" b="0">
                 <a:solidFill>
-                  <a:srgbClr val="404040"/>
+                  <a:srgbClr val="252525"/>
                 </a:solidFill>
               </a:rPr>
-              <a:t>・</a:t>
-            </a:r>
-          </a:p>
-        </p:txBody>
-      </p:sp>
-      <p:sp>
-        <p:nvSpPr>
-          <p:cNvPr id="10" name="TextBox 9"/>
+              <a:t>予約内訳を分析</a:t>
+            </a:r>
+          </a:p>
+        </p:txBody>
+      </p:sp>
+      <p:sp>
+        <p:nvSpPr>
+          <p:cNvPr id="15" name="TextBox 14"/>
           <p:cNvSpPr txBox="1"/>
           <p:nvPr/>
         </p:nvSpPr>
         <p:spPr>
           <a:xfrm>
-            <a:off x="731520" y="3346704"/>
-            <a:ext cx="10515600" cy="384048"/>
+            <a:off x="457200" y="4023360"/>
+            <a:ext cx="457200" cy="320040"/>
+          </a:xfrm>
+          <a:prstGeom prst="rect">
+            <a:avLst/>
+          </a:prstGeom>
+          <a:noFill/>
+        </p:spPr>
+        <p:txBody>
+          <a:bodyPr wrap="none">
+            <a:spAutoFit/>
+          </a:bodyPr>
+          <a:lstStyle/>
+          <a:p>
+            <a:pPr algn="l"/>
+            <a:r>
+              <a:rPr sz="1100" b="1">
+                <a:solidFill>
+                  <a:srgbClr val="1F3864"/>
+                </a:solidFill>
+              </a:rPr>
+              <a:t>04</a:t>
+            </a:r>
+          </a:p>
+        </p:txBody>
+      </p:sp>
+      <p:sp>
+        <p:nvSpPr>
+          <p:cNvPr id="16" name="Rectangle 15"/>
+          <p:cNvSpPr/>
+          <p:nvPr/>
+        </p:nvSpPr>
+        <p:spPr>
+          <a:xfrm>
+            <a:off x="457200" y="4361688"/>
+            <a:ext cx="5120640" cy="18288"/>
+          </a:xfrm>
+          <a:prstGeom prst="rect">
+            <a:avLst/>
+          </a:prstGeom>
+          <a:solidFill>
+            <a:srgbClr val="1F3864"/>
+          </a:solidFill>
+          <a:ln>
+            <a:noFill/>
+          </a:ln>
+        </p:spPr>
+        <p:style>
+          <a:lnRef idx="1">
+            <a:schemeClr val="accent1"/>
+          </a:lnRef>
+          <a:fillRef idx="3">
+            <a:schemeClr val="accent1"/>
+          </a:fillRef>
+          <a:effectRef idx="2">
+            <a:schemeClr val="accent1"/>
+          </a:effectRef>
+          <a:fontRef idx="minor">
+            <a:schemeClr val="lt1"/>
+          </a:fontRef>
+        </p:style>
+        <p:txBody>
+          <a:bodyPr rtlCol="0" anchor="ctr"/>
+          <a:lstStyle/>
+          <a:p>
+            <a:pPr algn="ctr"/>
+          </a:p>
+        </p:txBody>
+      </p:sp>
+      <p:sp>
+        <p:nvSpPr>
+          <p:cNvPr id="17" name="TextBox 16"/>
+          <p:cNvSpPr txBox="1"/>
+          <p:nvPr/>
+        </p:nvSpPr>
+        <p:spPr>
+          <a:xfrm>
+            <a:off x="457200" y="4407408"/>
+            <a:ext cx="5120640" cy="457200"/>
           </a:xfrm>
           <a:prstGeom prst="rect">
             <a:avLst/>
@@ -4054,26 +5969,182 @@
           <a:p>
             <a:pPr algn="l"/>
             <a:r>
+              <a:rPr sz="1100" b="0">
+                <a:solidFill>
+                  <a:srgbClr val="252525"/>
+                </a:solidFill>
+              </a:rPr>
+              <a:t>セールス・マーケ施策の実施</a:t>
+            </a:r>
+          </a:p>
+        </p:txBody>
+      </p:sp>
+      <p:sp>
+        <p:nvSpPr>
+          <p:cNvPr id="18" name="Rectangle 17"/>
+          <p:cNvSpPr/>
+          <p:nvPr/>
+        </p:nvSpPr>
+        <p:spPr>
+          <a:xfrm>
+            <a:off x="6355080" y="777240"/>
+            <a:ext cx="5394960" cy="4297680"/>
+          </a:xfrm>
+          <a:prstGeom prst="rect">
+            <a:avLst/>
+          </a:prstGeom>
+          <a:solidFill>
+            <a:srgbClr val="F0F5FB"/>
+          </a:solidFill>
+          <a:ln>
+            <a:solidFill>
+              <a:srgbClr val="ED7D31"/>
+            </a:solidFill>
+          </a:ln>
+        </p:spPr>
+        <p:style>
+          <a:lnRef idx="1">
+            <a:schemeClr val="accent1"/>
+          </a:lnRef>
+          <a:fillRef idx="3">
+            <a:schemeClr val="accent1"/>
+          </a:fillRef>
+          <a:effectRef idx="2">
+            <a:schemeClr val="accent1"/>
+          </a:effectRef>
+          <a:fontRef idx="minor">
+            <a:schemeClr val="lt1"/>
+          </a:fontRef>
+        </p:style>
+        <p:txBody>
+          <a:bodyPr rtlCol="0" anchor="ctr"/>
+          <a:lstStyle/>
+          <a:p>
+            <a:pPr algn="ctr"/>
+          </a:p>
+        </p:txBody>
+      </p:sp>
+      <p:sp>
+        <p:nvSpPr>
+          <p:cNvPr id="19" name="TextBox 18"/>
+          <p:cNvSpPr txBox="1"/>
+          <p:nvPr/>
+        </p:nvSpPr>
+        <p:spPr>
+          <a:xfrm>
+            <a:off x="6492240" y="822960"/>
+            <a:ext cx="5120640" cy="502920"/>
+          </a:xfrm>
+          <a:prstGeom prst="rect">
+            <a:avLst/>
+          </a:prstGeom>
+          <a:noFill/>
+        </p:spPr>
+        <p:txBody>
+          <a:bodyPr wrap="none">
+            <a:spAutoFit/>
+          </a:bodyPr>
+          <a:lstStyle/>
+          <a:p>
+            <a:pPr algn="l"/>
+            <a:r>
               <a:rPr sz="1400" b="1">
                 <a:solidFill>
-                  <a:srgbClr val="1F497D"/>
+                  <a:srgbClr val="ED7D31"/>
                 </a:solidFill>
               </a:rPr>
-              <a:t>【手間いらず自動 導入効果】</a:t>
-            </a:r>
-          </a:p>
-        </p:txBody>
-      </p:sp>
-      <p:sp>
-        <p:nvSpPr>
-          <p:cNvPr id="11" name="TextBox 10"/>
+              <a:t>【After】自動化＋判断業務へシフト</a:t>
+            </a:r>
+          </a:p>
+        </p:txBody>
+      </p:sp>
+      <p:sp>
+        <p:nvSpPr>
+          <p:cNvPr id="20" name="TextBox 19"/>
           <p:cNvSpPr txBox="1"/>
           <p:nvPr/>
         </p:nvSpPr>
         <p:spPr>
           <a:xfrm>
-            <a:off x="914400" y="3749040"/>
-            <a:ext cx="10332720" cy="384048"/>
+            <a:off x="6492240" y="1417320"/>
+            <a:ext cx="457200" cy="320040"/>
+          </a:xfrm>
+          <a:prstGeom prst="rect">
+            <a:avLst/>
+          </a:prstGeom>
+          <a:noFill/>
+        </p:spPr>
+        <p:txBody>
+          <a:bodyPr wrap="none">
+            <a:spAutoFit/>
+          </a:bodyPr>
+          <a:lstStyle/>
+          <a:p>
+            <a:pPr algn="l"/>
+            <a:r>
+              <a:rPr sz="1100" b="1">
+                <a:solidFill>
+                  <a:srgbClr val="ED7D31"/>
+                </a:solidFill>
+              </a:rPr>
+              <a:t>01</a:t>
+            </a:r>
+          </a:p>
+        </p:txBody>
+      </p:sp>
+      <p:sp>
+        <p:nvSpPr>
+          <p:cNvPr id="21" name="Rectangle 20"/>
+          <p:cNvSpPr/>
+          <p:nvPr/>
+        </p:nvSpPr>
+        <p:spPr>
+          <a:xfrm>
+            <a:off x="6492240" y="1755648"/>
+            <a:ext cx="5120640" cy="18288"/>
+          </a:xfrm>
+          <a:prstGeom prst="rect">
+            <a:avLst/>
+          </a:prstGeom>
+          <a:solidFill>
+            <a:srgbClr val="ED7D31"/>
+          </a:solidFill>
+          <a:ln>
+            <a:noFill/>
+          </a:ln>
+        </p:spPr>
+        <p:style>
+          <a:lnRef idx="1">
+            <a:schemeClr val="accent1"/>
+          </a:lnRef>
+          <a:fillRef idx="3">
+            <a:schemeClr val="accent1"/>
+          </a:fillRef>
+          <a:effectRef idx="2">
+            <a:schemeClr val="accent1"/>
+          </a:effectRef>
+          <a:fontRef idx="minor">
+            <a:schemeClr val="lt1"/>
+          </a:fontRef>
+        </p:style>
+        <p:txBody>
+          <a:bodyPr rtlCol="0" anchor="ctr"/>
+          <a:lstStyle/>
+          <a:p>
+            <a:pPr algn="ctr"/>
+          </a:p>
+        </p:txBody>
+      </p:sp>
+      <p:sp>
+        <p:nvSpPr>
+          <p:cNvPr id="22" name="TextBox 21"/>
+          <p:cNvSpPr txBox="1"/>
+          <p:nvPr/>
+        </p:nvSpPr>
+        <p:spPr>
+          <a:xfrm>
+            <a:off x="6492240" y="1801368"/>
+            <a:ext cx="5120640" cy="457200"/>
           </a:xfrm>
           <a:prstGeom prst="rect">
             <a:avLst/>
@@ -4088,26 +6159,104 @@
           <a:p>
             <a:pPr algn="l"/>
             <a:r>
-              <a:rPr sz="1300" b="0">
+              <a:rPr sz="1100" b="0">
                 <a:solidFill>
-                  <a:srgbClr val="404040"/>
+                  <a:srgbClr val="252525"/>
                 </a:solidFill>
               </a:rPr>
-              <a:t>・</a:t>
-            </a:r>
-          </a:p>
-        </p:txBody>
-      </p:sp>
-      <p:sp>
-        <p:nvSpPr>
-          <p:cNvPr id="12" name="TextBox 11"/>
+              <a:t>毎朝：直近予約・オンハンド
+確認 ＋ TPの動きを確認</a:t>
+            </a:r>
+          </a:p>
+        </p:txBody>
+      </p:sp>
+      <p:sp>
+        <p:nvSpPr>
+          <p:cNvPr id="23" name="TextBox 22"/>
           <p:cNvSpPr txBox="1"/>
           <p:nvPr/>
         </p:nvSpPr>
         <p:spPr>
           <a:xfrm>
-            <a:off x="914400" y="4151376"/>
-            <a:ext cx="10332720" cy="384048"/>
+            <a:off x="6492240" y="2286000"/>
+            <a:ext cx="457200" cy="320040"/>
+          </a:xfrm>
+          <a:prstGeom prst="rect">
+            <a:avLst/>
+          </a:prstGeom>
+          <a:noFill/>
+        </p:spPr>
+        <p:txBody>
+          <a:bodyPr wrap="none">
+            <a:spAutoFit/>
+          </a:bodyPr>
+          <a:lstStyle/>
+          <a:p>
+            <a:pPr algn="l"/>
+            <a:r>
+              <a:rPr sz="1100" b="1">
+                <a:solidFill>
+                  <a:srgbClr val="ED7D31"/>
+                </a:solidFill>
+              </a:rPr>
+              <a:t>02</a:t>
+            </a:r>
+          </a:p>
+        </p:txBody>
+      </p:sp>
+      <p:sp>
+        <p:nvSpPr>
+          <p:cNvPr id="24" name="Rectangle 23"/>
+          <p:cNvSpPr/>
+          <p:nvPr/>
+        </p:nvSpPr>
+        <p:spPr>
+          <a:xfrm>
+            <a:off x="6492240" y="2624328"/>
+            <a:ext cx="5120640" cy="18288"/>
+          </a:xfrm>
+          <a:prstGeom prst="rect">
+            <a:avLst/>
+          </a:prstGeom>
+          <a:solidFill>
+            <a:srgbClr val="ED7D31"/>
+          </a:solidFill>
+          <a:ln>
+            <a:noFill/>
+          </a:ln>
+        </p:spPr>
+        <p:style>
+          <a:lnRef idx="1">
+            <a:schemeClr val="accent1"/>
+          </a:lnRef>
+          <a:fillRef idx="3">
+            <a:schemeClr val="accent1"/>
+          </a:fillRef>
+          <a:effectRef idx="2">
+            <a:schemeClr val="accent1"/>
+          </a:effectRef>
+          <a:fontRef idx="minor">
+            <a:schemeClr val="lt1"/>
+          </a:fontRef>
+        </p:style>
+        <p:txBody>
+          <a:bodyPr rtlCol="0" anchor="ctr"/>
+          <a:lstStyle/>
+          <a:p>
+            <a:pPr algn="ctr"/>
+          </a:p>
+        </p:txBody>
+      </p:sp>
+      <p:sp>
+        <p:nvSpPr>
+          <p:cNvPr id="25" name="TextBox 24"/>
+          <p:cNvSpPr txBox="1"/>
+          <p:nvPr/>
+        </p:nvSpPr>
+        <p:spPr>
+          <a:xfrm>
+            <a:off x="6492240" y="2670048"/>
+            <a:ext cx="5120640" cy="457200"/>
           </a:xfrm>
           <a:prstGeom prst="rect">
             <a:avLst/>
@@ -4122,12 +6271,312 @@
           <a:p>
             <a:pPr algn="l"/>
             <a:r>
-              <a:rPr sz="1300" b="0">
+              <a:rPr sz="1100" b="0">
                 <a:solidFill>
-                  <a:srgbClr val="404040"/>
+                  <a:srgbClr val="252525"/>
                 </a:solidFill>
               </a:rPr>
-              <a:t>・</a:t>
+              <a:t>365日先まで自動調整
+（需要・在庫に応じてリアルタイム調整）</a:t>
+            </a:r>
+          </a:p>
+        </p:txBody>
+      </p:sp>
+      <p:sp>
+        <p:nvSpPr>
+          <p:cNvPr id="26" name="TextBox 25"/>
+          <p:cNvSpPr txBox="1"/>
+          <p:nvPr/>
+        </p:nvSpPr>
+        <p:spPr>
+          <a:xfrm>
+            <a:off x="6492240" y="3154680"/>
+            <a:ext cx="457200" cy="320040"/>
+          </a:xfrm>
+          <a:prstGeom prst="rect">
+            <a:avLst/>
+          </a:prstGeom>
+          <a:noFill/>
+        </p:spPr>
+        <p:txBody>
+          <a:bodyPr wrap="none">
+            <a:spAutoFit/>
+          </a:bodyPr>
+          <a:lstStyle/>
+          <a:p>
+            <a:pPr algn="l"/>
+            <a:r>
+              <a:rPr sz="1100" b="1">
+                <a:solidFill>
+                  <a:srgbClr val="ED7D31"/>
+                </a:solidFill>
+              </a:rPr>
+              <a:t>03</a:t>
+            </a:r>
+          </a:p>
+        </p:txBody>
+      </p:sp>
+      <p:sp>
+        <p:nvSpPr>
+          <p:cNvPr id="27" name="Rectangle 26"/>
+          <p:cNvSpPr/>
+          <p:nvPr/>
+        </p:nvSpPr>
+        <p:spPr>
+          <a:xfrm>
+            <a:off x="6492240" y="3493008"/>
+            <a:ext cx="5120640" cy="18288"/>
+          </a:xfrm>
+          <a:prstGeom prst="rect">
+            <a:avLst/>
+          </a:prstGeom>
+          <a:solidFill>
+            <a:srgbClr val="ED7D31"/>
+          </a:solidFill>
+          <a:ln>
+            <a:noFill/>
+          </a:ln>
+        </p:spPr>
+        <p:style>
+          <a:lnRef idx="1">
+            <a:schemeClr val="accent1"/>
+          </a:lnRef>
+          <a:fillRef idx="3">
+            <a:schemeClr val="accent1"/>
+          </a:fillRef>
+          <a:effectRef idx="2">
+            <a:schemeClr val="accent1"/>
+          </a:effectRef>
+          <a:fontRef idx="minor">
+            <a:schemeClr val="lt1"/>
+          </a:fontRef>
+        </p:style>
+        <p:txBody>
+          <a:bodyPr rtlCol="0" anchor="ctr"/>
+          <a:lstStyle/>
+          <a:p>
+            <a:pPr algn="ctr"/>
+          </a:p>
+        </p:txBody>
+      </p:sp>
+      <p:sp>
+        <p:nvSpPr>
+          <p:cNvPr id="28" name="TextBox 27"/>
+          <p:cNvSpPr txBox="1"/>
+          <p:nvPr/>
+        </p:nvSpPr>
+        <p:spPr>
+          <a:xfrm>
+            <a:off x="6492240" y="3538728"/>
+            <a:ext cx="5120640" cy="457200"/>
+          </a:xfrm>
+          <a:prstGeom prst="rect">
+            <a:avLst/>
+          </a:prstGeom>
+          <a:noFill/>
+        </p:spPr>
+        <p:txBody>
+          <a:bodyPr wrap="square">
+            <a:spAutoFit/>
+          </a:bodyPr>
+          <a:lstStyle/>
+          <a:p>
+            <a:pPr algn="l"/>
+            <a:r>
+              <a:rPr sz="1100" b="0">
+                <a:solidFill>
+                  <a:srgbClr val="252525"/>
+                </a:solidFill>
+              </a:rPr>
+              <a:t>予約内訳を多角的に分析
+（サイト別・属性・プラン・部屋）</a:t>
+            </a:r>
+          </a:p>
+        </p:txBody>
+      </p:sp>
+      <p:sp>
+        <p:nvSpPr>
+          <p:cNvPr id="29" name="TextBox 28"/>
+          <p:cNvSpPr txBox="1"/>
+          <p:nvPr/>
+        </p:nvSpPr>
+        <p:spPr>
+          <a:xfrm>
+            <a:off x="6492240" y="4023360"/>
+            <a:ext cx="457200" cy="320040"/>
+          </a:xfrm>
+          <a:prstGeom prst="rect">
+            <a:avLst/>
+          </a:prstGeom>
+          <a:noFill/>
+        </p:spPr>
+        <p:txBody>
+          <a:bodyPr wrap="none">
+            <a:spAutoFit/>
+          </a:bodyPr>
+          <a:lstStyle/>
+          <a:p>
+            <a:pPr algn="l"/>
+            <a:r>
+              <a:rPr sz="1100" b="1">
+                <a:solidFill>
+                  <a:srgbClr val="ED7D31"/>
+                </a:solidFill>
+              </a:rPr>
+              <a:t>04</a:t>
+            </a:r>
+          </a:p>
+        </p:txBody>
+      </p:sp>
+      <p:sp>
+        <p:nvSpPr>
+          <p:cNvPr id="30" name="Rectangle 29"/>
+          <p:cNvSpPr/>
+          <p:nvPr/>
+        </p:nvSpPr>
+        <p:spPr>
+          <a:xfrm>
+            <a:off x="6492240" y="4361688"/>
+            <a:ext cx="5120640" cy="18288"/>
+          </a:xfrm>
+          <a:prstGeom prst="rect">
+            <a:avLst/>
+          </a:prstGeom>
+          <a:solidFill>
+            <a:srgbClr val="ED7D31"/>
+          </a:solidFill>
+          <a:ln>
+            <a:noFill/>
+          </a:ln>
+        </p:spPr>
+        <p:style>
+          <a:lnRef idx="1">
+            <a:schemeClr val="accent1"/>
+          </a:lnRef>
+          <a:fillRef idx="3">
+            <a:schemeClr val="accent1"/>
+          </a:fillRef>
+          <a:effectRef idx="2">
+            <a:schemeClr val="accent1"/>
+          </a:effectRef>
+          <a:fontRef idx="minor">
+            <a:schemeClr val="lt1"/>
+          </a:fontRef>
+        </p:style>
+        <p:txBody>
+          <a:bodyPr rtlCol="0" anchor="ctr"/>
+          <a:lstStyle/>
+          <a:p>
+            <a:pPr algn="ctr"/>
+          </a:p>
+        </p:txBody>
+      </p:sp>
+      <p:sp>
+        <p:nvSpPr>
+          <p:cNvPr id="31" name="TextBox 30"/>
+          <p:cNvSpPr txBox="1"/>
+          <p:nvPr/>
+        </p:nvSpPr>
+        <p:spPr>
+          <a:xfrm>
+            <a:off x="6492240" y="4407408"/>
+            <a:ext cx="5120640" cy="457200"/>
+          </a:xfrm>
+          <a:prstGeom prst="rect">
+            <a:avLst/>
+          </a:prstGeom>
+          <a:noFill/>
+        </p:spPr>
+        <p:txBody>
+          <a:bodyPr wrap="square">
+            <a:spAutoFit/>
+          </a:bodyPr>
+          <a:lstStyle/>
+          <a:p>
+            <a:pPr algn="l"/>
+            <a:r>
+              <a:rPr sz="1100" b="0">
+                <a:solidFill>
+                  <a:srgbClr val="252525"/>
+                </a:solidFill>
+              </a:rPr>
+              <a:t>セールス・マーケ施策の実施</a:t>
+            </a:r>
+          </a:p>
+        </p:txBody>
+      </p:sp>
+      <p:sp>
+        <p:nvSpPr>
+          <p:cNvPr id="32" name="Rectangle 31"/>
+          <p:cNvSpPr/>
+          <p:nvPr/>
+        </p:nvSpPr>
+        <p:spPr>
+          <a:xfrm>
+            <a:off x="320040" y="5349240"/>
+            <a:ext cx="11521440" cy="594360"/>
+          </a:xfrm>
+          <a:prstGeom prst="rect">
+            <a:avLst/>
+          </a:prstGeom>
+          <a:solidFill>
+            <a:srgbClr val="D6E4F0"/>
+          </a:solidFill>
+          <a:ln>
+            <a:noFill/>
+          </a:ln>
+        </p:spPr>
+        <p:style>
+          <a:lnRef idx="1">
+            <a:schemeClr val="accent1"/>
+          </a:lnRef>
+          <a:fillRef idx="3">
+            <a:schemeClr val="accent1"/>
+          </a:fillRef>
+          <a:effectRef idx="2">
+            <a:schemeClr val="accent1"/>
+          </a:effectRef>
+          <a:fontRef idx="minor">
+            <a:schemeClr val="lt1"/>
+          </a:fontRef>
+        </p:style>
+        <p:txBody>
+          <a:bodyPr rtlCol="0" anchor="ctr"/>
+          <a:lstStyle/>
+          <a:p>
+            <a:pPr algn="ctr"/>
+          </a:p>
+        </p:txBody>
+      </p:sp>
+      <p:sp>
+        <p:nvSpPr>
+          <p:cNvPr id="33" name="TextBox 32"/>
+          <p:cNvSpPr txBox="1"/>
+          <p:nvPr/>
+        </p:nvSpPr>
+        <p:spPr>
+          <a:xfrm>
+            <a:off x="502920" y="5422392"/>
+            <a:ext cx="11247120" cy="484632"/>
+          </a:xfrm>
+          <a:prstGeom prst="rect">
+            <a:avLst/>
+          </a:prstGeom>
+          <a:noFill/>
+        </p:spPr>
+        <p:txBody>
+          <a:bodyPr wrap="square">
+            <a:spAutoFit/>
+          </a:bodyPr>
+          <a:lstStyle/>
+          <a:p>
+            <a:r>
+              <a:rPr sz="1200">
+                <a:solidFill>
+                  <a:srgbClr val="252525"/>
+                </a:solidFill>
+              </a:rPr>
+              <a:t>✅  価格調整の工数削減により、分析・戦略業務へリソースを集中できる運用へ転換。</a:t>
             </a:r>
           </a:p>
         </p:txBody>

</xml_diff>